<commit_message>
poster updaate for meeting
</commit_message>
<xml_diff>
--- a/keelinjoyce/fos poster/keelinjoyce_fos2026_syeseminar.pptx
+++ b/keelinjoyce/fos poster/keelinjoyce_fos2026_syeseminar.pptx
@@ -124,6 +124,34 @@
     </p:ext>
   </p:extLst>
 </p:presentation>
+</file>
+
+<file path=ppt/authors.xml><?xml version="1.0" encoding="utf-8"?>
+<p188:authorLst xmlns:a="http://schemas.openxmlformats.org/drawingml/2006/main" xmlns:r="http://schemas.openxmlformats.org/officeDocument/2006/relationships" xmlns:p188="http://schemas.microsoft.com/office/powerpoint/2018/8/main">
+  <p188:author id="{208AC820-044B-0798-D9CC-D44C4EB0E508}" name="Keelin Joyce" initials="KJ" userId="S::kjoyc22@stlawu.edu::1e767e3b-81c5-43cc-b057-c8fb551bb60b" providerId="AD"/>
+</p188:authorLst>
+</file>
+
+<file path=ppt/comments/modernComment_100_CAC8111D.xml><?xml version="1.0" encoding="utf-8"?>
+<p188:cmLst xmlns:a="http://schemas.openxmlformats.org/drawingml/2006/main" xmlns:r="http://schemas.openxmlformats.org/officeDocument/2006/relationships" xmlns:p188="http://schemas.microsoft.com/office/powerpoint/2018/8/main">
+  <p188:cm id="{93DB5D02-4641-A246-B262-68EDFDC45DF7}" authorId="{208AC820-044B-0798-D9CC-D44C4EB0E508}" created="2026-04-13T14:52:39.519">
+    <ac:deMkLst xmlns:ac="http://schemas.microsoft.com/office/drawing/2013/main/command">
+      <pc:docMk xmlns:pc="http://schemas.microsoft.com/office/powerpoint/2013/main/command"/>
+      <pc:sldMk xmlns:pc="http://schemas.microsoft.com/office/powerpoint/2013/main/command" cId="3402109213" sldId="256"/>
+      <ac:picMk id="34" creationId="{E775E83E-5044-91E4-9222-29FAB91ADB4A}"/>
+    </ac:deMkLst>
+    <p188:txBody>
+      <a:bodyPr/>
+      <a:lstStyle/>
+      <a:p>
+        <a:r>
+          <a:rPr lang="en-US"/>
+          <a:t>distance from goal</a:t>
+        </a:r>
+      </a:p>
+    </p188:txBody>
+  </p188:cm>
+</p188:cmLst>
 </file>
 
 <file path=ppt/notesMasters/notesMaster1.xml><?xml version="1.0" encoding="utf-8"?>
@@ -3487,8 +3515,8 @@
         </p:nvSpPr>
         <p:spPr>
           <a:xfrm>
-            <a:off x="14546601" y="25741728"/>
-            <a:ext cx="13767838" cy="4392137"/>
+            <a:off x="28791557" y="26983097"/>
+            <a:ext cx="13767838" cy="2990538"/>
           </a:xfrm>
           <a:prstGeom prst="rect">
             <a:avLst/>
@@ -3533,7 +3561,7 @@
                 <a:latin typeface="Arial" panose="020B0604020202020204" pitchFamily="34" charset="0"/>
                 <a:cs typeface="Arial" panose="020B0604020202020204" pitchFamily="34" charset="0"/>
               </a:rPr>
-              <a:t>I would like to thank Dr. Ivan Ramler for his continued guidance and support of this project.</a:t>
+              <a:t>I would like to thank Dr. Cathy Crosby and the university’s IRB for their work in approving our methods of data collection.</a:t>
             </a:r>
           </a:p>
           <a:p>
@@ -3552,7 +3580,7 @@
                 <a:latin typeface="Arial" panose="020B0604020202020204" pitchFamily="34" charset="0"/>
                 <a:cs typeface="Arial" panose="020B0604020202020204" pitchFamily="34" charset="0"/>
               </a:rPr>
-              <a:t>I would also like to thank Dr. Cathy Crosby and the university’s IRB for their work in approving our methods of data collection.</a:t>
+              <a:t>Thank you to Josh Larson, Phoebe Jones, Cooper Olney, and Faith Rhinehart for wrangling and cleaning the powerlifting data.</a:t>
             </a:r>
           </a:p>
           <a:p>
@@ -3571,25 +3599,6 @@
                 <a:latin typeface="Arial" panose="020B0604020202020204" pitchFamily="34" charset="0"/>
                 <a:cs typeface="Arial" panose="020B0604020202020204" pitchFamily="34" charset="0"/>
               </a:rPr>
-              <a:t>Thank you to Josh Larson, Phoebe Jones, Cooper Olney, and Faith Rhinehart for wrangling and cleaning the powerlifting data.</a:t>
-            </a:r>
-          </a:p>
-          <a:p>
-            <a:pPr marL="457200" indent="-457200" algn="l" rtl="0" fontAlgn="base">
-              <a:spcBef>
-                <a:spcPts val="0"/>
-              </a:spcBef>
-              <a:spcAft>
-                <a:spcPts val="0"/>
-              </a:spcAft>
-              <a:buFont typeface="Arial" panose="020B0604020202020204" pitchFamily="34" charset="0"/>
-              <a:buChar char="•"/>
-            </a:pPr>
-            <a:r>
-              <a:rPr lang="en-US" sz="3200" dirty="0">
-                <a:latin typeface="Arial" panose="020B0604020202020204" pitchFamily="34" charset="0"/>
-                <a:cs typeface="Arial" panose="020B0604020202020204" pitchFamily="34" charset="0"/>
-              </a:rPr>
               <a:t>Thank you to the St. Lawrence University Crew Team for their time, support, and consent to collect data from their winter training season.</a:t>
             </a:r>
           </a:p>
@@ -3603,8 +3612,8 @@
         </p:nvSpPr>
         <p:spPr>
           <a:xfrm>
-            <a:off x="14494609" y="6355010"/>
-            <a:ext cx="13767838" cy="15310856"/>
+            <a:off x="14494609" y="6931074"/>
+            <a:ext cx="13767838" cy="19547268"/>
           </a:xfrm>
           <a:prstGeom prst="rect">
             <a:avLst/>
@@ -3834,24 +3843,6 @@
             </a:endParaRPr>
           </a:p>
           <a:p>
-            <a:pPr algn="l" rtl="0" fontAlgn="base">
-              <a:spcBef>
-                <a:spcPts val="0"/>
-              </a:spcBef>
-              <a:spcAft>
-                <a:spcPts val="0"/>
-              </a:spcAft>
-            </a:pPr>
-            <a:endParaRPr lang="en-US" sz="2800" b="0" i="0" u="none" strike="noStrike" dirty="0">
-              <a:solidFill>
-                <a:srgbClr val="000000"/>
-              </a:solidFill>
-              <a:effectLst/>
-              <a:latin typeface="Arial" panose="020B0604020202020204" pitchFamily="34" charset="0"/>
-              <a:cs typeface="Arial" panose="020B0604020202020204" pitchFamily="34" charset="0"/>
-            </a:endParaRPr>
-          </a:p>
-          <a:p>
             <a:pPr algn="l" rtl="0">
               <a:spcBef>
                 <a:spcPts val="0"/>
@@ -3860,6 +3851,23 @@
                 <a:spcPts val="0"/>
               </a:spcAft>
             </a:pPr>
+            <a:endParaRPr lang="en-US" sz="4400" b="1" i="0" u="none" strike="noStrike" dirty="0">
+              <a:solidFill>
+                <a:srgbClr val="000000"/>
+              </a:solidFill>
+              <a:effectLst/>
+              <a:latin typeface="Arial" panose="020B0604020202020204" pitchFamily="34" charset="0"/>
+            </a:endParaRPr>
+          </a:p>
+          <a:p>
+            <a:pPr algn="l" rtl="0">
+              <a:spcBef>
+                <a:spcPts val="0"/>
+              </a:spcBef>
+              <a:spcAft>
+                <a:spcPts val="0"/>
+              </a:spcAft>
+            </a:pPr>
             <a:r>
               <a:rPr lang="en-US" sz="4400" b="1" i="0" u="none" strike="noStrike" dirty="0">
                 <a:solidFill>
@@ -3869,6 +3877,38 @@
                 <a:latin typeface="Arial" panose="020B0604020202020204" pitchFamily="34" charset="0"/>
               </a:rPr>
               <a:t>Powerlifting</a:t>
+            </a:r>
+          </a:p>
+          <a:p>
+            <a:pPr marL="457200" indent="-457200">
+              <a:buFont typeface="Arial" panose="020B0604020202020204" pitchFamily="34" charset="0"/>
+              <a:buChar char="•"/>
+            </a:pPr>
+            <a:r>
+              <a:rPr lang="en-US" sz="3200" dirty="0">
+                <a:solidFill>
+                  <a:schemeClr val="tx1"/>
+                </a:solidFill>
+                <a:latin typeface="Arial" panose="020B0604020202020204" pitchFamily="34" charset="0"/>
+                <a:cs typeface="Arial" panose="020B0604020202020204" pitchFamily="34" charset="0"/>
+              </a:rPr>
+              <a:t>In powerlifting competitions, athletes compete in three compound events (benching, squatting, and deadlifting) to lift as much weight as possible.</a:t>
+            </a:r>
+          </a:p>
+          <a:p>
+            <a:pPr marL="457200" indent="-457200">
+              <a:buFont typeface="Arial" panose="020B0604020202020204" pitchFamily="34" charset="0"/>
+              <a:buChar char="•"/>
+            </a:pPr>
+            <a:r>
+              <a:rPr lang="en-US" sz="3200" dirty="0">
+                <a:solidFill>
+                  <a:schemeClr val="tx1"/>
+                </a:solidFill>
+                <a:latin typeface="Arial" panose="020B0604020202020204" pitchFamily="34" charset="0"/>
+                <a:cs typeface="Arial" panose="020B0604020202020204" pitchFamily="34" charset="0"/>
+              </a:rPr>
+              <a:t>This module focuses specifically on female benching weight, but there are extensions for other exercises as well as analyses for males.</a:t>
             </a:r>
           </a:p>
           <a:p>
@@ -3913,7 +3953,7 @@
                 <a:ea typeface="Lato" panose="020F0502020204030203" pitchFamily="34" charset="0"/>
                 <a:cs typeface="Arial" panose="020B0604020202020204" pitchFamily="34" charset="0"/>
               </a:rPr>
-              <a:t>ANOVA (analysis of variance) is typically used for determining if there is a statistical discernibility between two or more groups, but can only be used when the groups are normally distributed.</a:t>
+              <a:t>ANOVA (analysis of variance) is typically used for determining if there is a statistical discernibility between two or more groups but can only be used when the groups are normally distributed and the means are not the meaningful metric.</a:t>
             </a:r>
             <a:endParaRPr lang="en-US" sz="3200" b="0" i="0" u="none" strike="noStrike" dirty="0">
               <a:solidFill>
@@ -3946,7 +3986,30 @@
                 <a:ea typeface="Lato" panose="020F0502020204030203" pitchFamily="34" charset="0"/>
                 <a:cs typeface="Arial" panose="020B0604020202020204" pitchFamily="34" charset="0"/>
               </a:rPr>
-              <a:t>In this case, the groups are not normally distributed, so the assumptions required to use ANOVA testing are violated and the Kruskal-Wallis test is used.</a:t>
+              <a:t>In this case, the groups are not normally distributed, so the assumptions required to use ANOVA testing are violated and the Kruskal-</a:t>
+            </a:r>
+            <a:r>
+              <a:rPr lang="en-US" sz="3200" dirty="0">
+                <a:solidFill>
+                  <a:srgbClr val="000000"/>
+                </a:solidFill>
+                <a:latin typeface="Arial" panose="020B0604020202020204" pitchFamily="34" charset="0"/>
+                <a:ea typeface="Lato" panose="020F0502020204030203" pitchFamily="34" charset="0"/>
+                <a:cs typeface="Arial" panose="020B0604020202020204" pitchFamily="34" charset="0"/>
+              </a:rPr>
+              <a:t>W</a:t>
+            </a:r>
+            <a:r>
+              <a:rPr lang="en-US" sz="3200" b="0" i="0" u="none" strike="noStrike" dirty="0">
+                <a:solidFill>
+                  <a:srgbClr val="000000"/>
+                </a:solidFill>
+                <a:effectLst/>
+                <a:latin typeface="Arial" panose="020B0604020202020204" pitchFamily="34" charset="0"/>
+                <a:ea typeface="Lato" panose="020F0502020204030203" pitchFamily="34" charset="0"/>
+                <a:cs typeface="Arial" panose="020B0604020202020204" pitchFamily="34" charset="0"/>
+              </a:rPr>
+              <a:t>allis test is used.</a:t>
             </a:r>
           </a:p>
           <a:p>
@@ -3986,6 +4049,64 @@
             </a:r>
           </a:p>
           <a:p>
+            <a:pPr marL="457200" indent="-457200" algn="l" rtl="0">
+              <a:spcBef>
+                <a:spcPts val="0"/>
+              </a:spcBef>
+              <a:spcAft>
+                <a:spcPts val="0"/>
+              </a:spcAft>
+              <a:buFont typeface="Arial" panose="020B0604020202020204" pitchFamily="34" charset="0"/>
+              <a:buChar char="•"/>
+            </a:pPr>
+            <a:r>
+              <a:rPr lang="en-US" sz="3200" b="0" i="0" u="none" strike="noStrike" dirty="0">
+                <a:solidFill>
+                  <a:srgbClr val="000000"/>
+                </a:solidFill>
+                <a:effectLst/>
+                <a:latin typeface="Arial" panose="020B0604020202020204" pitchFamily="34" charset="0"/>
+                <a:cs typeface="Arial" panose="020B0604020202020204" pitchFamily="34" charset="0"/>
+              </a:rPr>
+              <a:t>During winter training, rowers practice using ergometers (ergs) to maintain and build fitness off of the water.</a:t>
+            </a:r>
+          </a:p>
+          <a:p>
+            <a:pPr marL="457200" indent="-457200">
+              <a:buFont typeface="Arial" panose="020B0604020202020204" pitchFamily="34" charset="0"/>
+              <a:buChar char="•"/>
+            </a:pPr>
+            <a:r>
+              <a:rPr lang="en-US" sz="3200" b="0" i="0" u="none" strike="noStrike" dirty="0">
+                <a:solidFill>
+                  <a:srgbClr val="000000"/>
+                </a:solidFill>
+                <a:effectLst/>
+                <a:latin typeface="Arial" panose="020B0604020202020204" pitchFamily="34" charset="0"/>
+                <a:cs typeface="Arial" panose="020B0604020202020204" pitchFamily="34" charset="0"/>
+              </a:rPr>
+              <a:t>Ergs share many metrics of fitness including time and duration of th</a:t>
+            </a:r>
+            <a:r>
+              <a:rPr lang="en-US" sz="3200" dirty="0">
+                <a:solidFill>
+                  <a:srgbClr val="000000"/>
+                </a:solidFill>
+                <a:latin typeface="Arial" panose="020B0604020202020204" pitchFamily="34" charset="0"/>
+                <a:cs typeface="Arial" panose="020B0604020202020204" pitchFamily="34" charset="0"/>
+              </a:rPr>
+              <a:t>e piece and instantly shares the rower’s split (time per 500 meters).</a:t>
+            </a:r>
+            <a:endParaRPr lang="en-US" sz="3200" b="0" i="0" u="none" strike="noStrike" dirty="0">
+              <a:solidFill>
+                <a:srgbClr val="000000"/>
+              </a:solidFill>
+              <a:effectLst/>
+              <a:latin typeface="Arial" panose="020B0604020202020204" pitchFamily="34" charset="0"/>
+              <a:cs typeface="Arial" panose="020B0604020202020204" pitchFamily="34" charset="0"/>
+            </a:endParaRPr>
+          </a:p>
+          <a:p>
             <a:pPr marL="457200" indent="-457200">
               <a:buFont typeface="Arial" panose="020B0604020202020204" pitchFamily="34" charset="0"/>
               <a:buChar char="•"/>
@@ -4013,7 +4134,7 @@
                 <a:ea typeface="Lato" panose="020F0502020204030203" pitchFamily="34" charset="0"/>
                 <a:cs typeface="Arial" panose="020B0604020202020204" pitchFamily="34" charset="0"/>
               </a:rPr>
-              <a:t>This module is aimed at filling that need for confidence intervals of proportions at an introductory level.</a:t>
+              <a:t>This module is aimed at filling that need using confidence intervals of proportions at an introductory level.</a:t>
             </a:r>
           </a:p>
           <a:p>
@@ -4030,7 +4151,7 @@
                 <a:ea typeface="Lato" panose="020F0502020204030203" pitchFamily="34" charset="0"/>
                 <a:cs typeface="Arial" panose="020B0604020202020204" pitchFamily="34" charset="0"/>
               </a:rPr>
-              <a:t>The data collected is a current team snapshot and can be further </a:t>
+              <a:t>The data collected is a current snapshot of the St. Lawrence University rowing team and can be further analyzed with updated data in the future.</a:t>
             </a:r>
             <a:endParaRPr lang="en-US" sz="3200" b="0" i="0" u="none" strike="noStrike" dirty="0">
               <a:solidFill>
@@ -4152,7 +4273,7 @@
                 <a:ea typeface="Lato" panose="020F0502020204030203" pitchFamily="34" charset="0"/>
                 <a:cs typeface="Arial" panose="020B0604020202020204" pitchFamily="34" charset="0"/>
               </a:rPr>
-              <a:t>Determine if the lifting capacity for powerlifters is discernible between age classes</a:t>
+              <a:t>Determine if the lifting capacity for powerlifters is discernible between age classes.</a:t>
             </a:r>
           </a:p>
           <a:p>
@@ -4175,7 +4296,7 @@
                 <a:ea typeface="Lato" panose="020F0502020204030203" pitchFamily="34" charset="0"/>
                 <a:cs typeface="Arial" panose="020B0604020202020204" pitchFamily="34" charset="0"/>
               </a:rPr>
-              <a:t>Run a test of multiple comparison (Dunn’s Test) to determine which groups are statistically discernible from each other</a:t>
+              <a:t>Run a test of multiple comparison (Dunn’s Test) to determine which groups are statistically discernible from each other.</a:t>
             </a:r>
             <a:endParaRPr lang="en-US" sz="3000" b="0" i="0" u="none" strike="noStrike" dirty="0">
               <a:solidFill>
@@ -4372,8 +4493,8 @@
         </p:nvSpPr>
         <p:spPr>
           <a:xfrm>
-            <a:off x="369997" y="5346899"/>
-            <a:ext cx="13767838" cy="923330"/>
+            <a:off x="369997" y="5339348"/>
+            <a:ext cx="13767838" cy="1015663"/>
           </a:xfrm>
           <a:prstGeom prst="rect">
             <a:avLst/>
@@ -4390,7 +4511,7 @@
           <a:p>
             <a:pPr algn="ctr" eaLnBrk="1" hangingPunct="1"/>
             <a:r>
-              <a:rPr lang="en-US" sz="5400" b="1" dirty="0">
+              <a:rPr lang="en-US" sz="6000" b="1" dirty="0">
                 <a:latin typeface="Arial" panose="020B0604020202020204" pitchFamily="34" charset="0"/>
                 <a:cs typeface="Arial" panose="020B0604020202020204" pitchFamily="34" charset="0"/>
               </a:rPr>
@@ -4413,8 +4534,8 @@
         </p:nvSpPr>
         <p:spPr>
           <a:xfrm>
-            <a:off x="14520343" y="5346899"/>
-            <a:ext cx="13767838" cy="923330"/>
+            <a:off x="14520343" y="5339348"/>
+            <a:ext cx="13767838" cy="1015663"/>
           </a:xfrm>
           <a:prstGeom prst="rect">
             <a:avLst/>
@@ -4431,7 +4552,7 @@
           <a:p>
             <a:pPr algn="ctr" eaLnBrk="1" hangingPunct="1"/>
             <a:r>
-              <a:rPr lang="en-US" sz="5400" b="1" dirty="0">
+              <a:rPr lang="en-US" sz="6000" b="1" dirty="0">
                 <a:latin typeface="Arial" panose="020B0604020202020204" pitchFamily="34" charset="0"/>
                 <a:cs typeface="Arial" panose="020B0604020202020204" pitchFamily="34" charset="0"/>
               </a:rPr>
@@ -4454,8 +4575,8 @@
         </p:nvSpPr>
         <p:spPr>
           <a:xfrm>
-            <a:off x="28670690" y="5346899"/>
-            <a:ext cx="13767838" cy="923330"/>
+            <a:off x="28670690" y="5339348"/>
+            <a:ext cx="13767838" cy="1015663"/>
           </a:xfrm>
           <a:prstGeom prst="rect">
             <a:avLst/>
@@ -4472,7 +4593,7 @@
           <a:p>
             <a:pPr algn="ctr" eaLnBrk="1" hangingPunct="1"/>
             <a:r>
-              <a:rPr lang="en-US" sz="5400" b="1" dirty="0">
+              <a:rPr lang="en-US" sz="6000" b="1" dirty="0">
                 <a:latin typeface="Arial" panose="020B0604020202020204" pitchFamily="34" charset="0"/>
                 <a:cs typeface="Arial" panose="020B0604020202020204" pitchFamily="34" charset="0"/>
               </a:rPr>
@@ -4495,8 +4616,8 @@
         </p:nvSpPr>
         <p:spPr>
           <a:xfrm>
-            <a:off x="28631769" y="6501170"/>
-            <a:ext cx="13767838" cy="3547693"/>
+            <a:off x="28631769" y="6355011"/>
+            <a:ext cx="13767838" cy="3298390"/>
           </a:xfrm>
           <a:prstGeom prst="rect">
             <a:avLst/>
@@ -4527,7 +4648,7 @@
           <a:lstStyle/>
           <a:p>
             <a:r>
-              <a:rPr lang="en-US" sz="4400" b="1" i="0" u="none" strike="noStrike" dirty="0">
+              <a:rPr lang="en-US" sz="4000" b="1" i="0" u="none" strike="noStrike" dirty="0">
                 <a:solidFill>
                   <a:srgbClr val="000000"/>
                 </a:solidFill>
@@ -4536,7 +4657,7 @@
               </a:rPr>
               <a:t>Motivation</a:t>
             </a:r>
-            <a:endParaRPr lang="en-US" sz="4400" dirty="0">
+            <a:endParaRPr lang="en-US" sz="4000" dirty="0">
               <a:solidFill>
                 <a:srgbClr val="000000"/>
               </a:solidFill>
@@ -4564,7 +4685,7 @@
                 <a:latin typeface="Arial" panose="020B0604020202020204" pitchFamily="34" charset="0"/>
                 <a:cs typeface="Arial" panose="020B0604020202020204" pitchFamily="34" charset="0"/>
               </a:rPr>
-              <a:t>During winter training, rowers practice using ergometers (ergs) to maintain and build fitness off of the water.</a:t>
+              <a:t>Prior to completing test pieces to assess their fitness at any given point in the training cycle, rowers are encouraged by their coach to set “ambitious, yet achievable” goals that they aim for </a:t>
             </a:r>
           </a:p>
           <a:p>
@@ -4579,6 +4700,16 @@
               <a:buChar char="•"/>
             </a:pPr>
             <a:r>
+              <a:rPr lang="en-US" sz="3000" dirty="0">
+                <a:solidFill>
+                  <a:srgbClr val="000000"/>
+                </a:solidFill>
+                <a:latin typeface="Arial" panose="020B0604020202020204" pitchFamily="34" charset="0"/>
+                <a:cs typeface="Arial" panose="020B0604020202020204" pitchFamily="34" charset="0"/>
+              </a:rPr>
+              <a:t>T</a:t>
+            </a:r>
+            <a:r>
               <a:rPr lang="en-US" sz="3000" b="0" i="0" u="none" strike="noStrike" dirty="0">
                 <a:solidFill>
                   <a:srgbClr val="000000"/>
@@ -4587,48 +4718,7 @@
                 <a:latin typeface="Arial" panose="020B0604020202020204" pitchFamily="34" charset="0"/>
                 <a:cs typeface="Arial" panose="020B0604020202020204" pitchFamily="34" charset="0"/>
               </a:rPr>
-              <a:t>Ergs share many metrics of fitness including time and duration of th</a:t>
-            </a:r>
-            <a:r>
-              <a:rPr lang="en-US" sz="3000" dirty="0">
-                <a:solidFill>
-                  <a:srgbClr val="000000"/>
-                </a:solidFill>
-                <a:latin typeface="Arial" panose="020B0604020202020204" pitchFamily="34" charset="0"/>
-                <a:cs typeface="Arial" panose="020B0604020202020204" pitchFamily="34" charset="0"/>
-              </a:rPr>
-              <a:t>e piece and instantly shares the rower’s split (time per 500 meters).</a:t>
-            </a:r>
-            <a:endParaRPr lang="en-US" sz="3000" b="0" i="0" u="none" strike="noStrike" dirty="0">
-              <a:solidFill>
-                <a:srgbClr val="000000"/>
-              </a:solidFill>
-              <a:effectLst/>
-              <a:latin typeface="Arial" panose="020B0604020202020204" pitchFamily="34" charset="0"/>
-              <a:cs typeface="Arial" panose="020B0604020202020204" pitchFamily="34" charset="0"/>
-            </a:endParaRPr>
-          </a:p>
-          <a:p>
-            <a:pPr marL="457200" indent="-457200" algn="l" rtl="0">
-              <a:spcBef>
-                <a:spcPts val="0"/>
-              </a:spcBef>
-              <a:spcAft>
-                <a:spcPts val="0"/>
-              </a:spcAft>
-              <a:buFont typeface="Arial" panose="020B0604020202020204" pitchFamily="34" charset="0"/>
-              <a:buChar char="•"/>
-            </a:pPr>
-            <a:r>
-              <a:rPr lang="en-US" sz="3000" b="0" i="0" u="none" strike="noStrike" dirty="0">
-                <a:solidFill>
-                  <a:srgbClr val="000000"/>
-                </a:solidFill>
-                <a:effectLst/>
-                <a:latin typeface="Arial" panose="020B0604020202020204" pitchFamily="34" charset="0"/>
-                <a:cs typeface="Arial" panose="020B0604020202020204" pitchFamily="34" charset="0"/>
-              </a:rPr>
-              <a:t>Rowers are encouraged to set “ambitious, yet achievable” goals before their piece, but the single proportion confidence interval tells us what proportion of athletes are setting ambitious goals.</a:t>
+              <a:t>he single proportion confidence interval tells us what proportion of athletes are setting ambitious goals.</a:t>
             </a:r>
           </a:p>
         </p:txBody>
@@ -4647,8 +4737,8 @@
         </p:nvSpPr>
         <p:spPr>
           <a:xfrm>
-            <a:off x="14491494" y="24873841"/>
-            <a:ext cx="13751514" cy="923330"/>
+            <a:off x="28678417" y="25974286"/>
+            <a:ext cx="13751514" cy="830997"/>
           </a:xfrm>
           <a:prstGeom prst="rect">
             <a:avLst/>
@@ -4665,7 +4755,7 @@
           <a:p>
             <a:pPr algn="ctr" eaLnBrk="1" hangingPunct="1"/>
             <a:r>
-              <a:rPr lang="en-US" sz="5400" b="1" dirty="0">
+              <a:rPr lang="en-US" sz="4800" b="1" dirty="0">
                 <a:latin typeface="Arial" panose="020B0604020202020204" pitchFamily="34" charset="0"/>
                 <a:cs typeface="Arial" panose="020B0604020202020204" pitchFamily="34" charset="0"/>
               </a:rPr>
@@ -4733,8 +4823,8 @@
         </p:nvSpPr>
         <p:spPr>
           <a:xfrm>
-            <a:off x="634530" y="18358080"/>
-            <a:ext cx="13656134" cy="4126724"/>
+            <a:off x="203236" y="17961761"/>
+            <a:ext cx="14290664" cy="4520362"/>
           </a:xfrm>
           <a:prstGeom prst="rect">
             <a:avLst/>
@@ -4782,7 +4872,7 @@
                 <a:ea typeface="Verdana" panose="020B0604030504040204" pitchFamily="34" charset="0"/>
                 <a:cs typeface="Arial" panose="020B0604020202020204" pitchFamily="34" charset="0"/>
               </a:rPr>
-              <a:t>P-values</a:t>
+              <a:t>  P-values</a:t>
             </a:r>
             <a:endParaRPr lang="en-US" sz="3000" b="0" i="0" u="none" strike="noStrike" dirty="0">
               <a:solidFill>
@@ -4813,7 +4903,7 @@
                 <a:latin typeface="Arial" panose="020B0604020202020204" pitchFamily="34" charset="0"/>
                 <a:cs typeface="Arial" panose="020B0604020202020204" pitchFamily="34" charset="0"/>
               </a:rPr>
-              <a:t>Because there are 14 groups each being compared with each other, there are too many p-values to determine whether they are statistically discernible. </a:t>
+              <a:t>Because there are 14 groups each being compared with each other, there are too many p-values to easily sort through individual results</a:t>
             </a:r>
           </a:p>
           <a:p>
@@ -4828,28 +4918,6 @@
               <a:buChar char="•"/>
             </a:pPr>
             <a:r>
-              <a:rPr lang="en-US" sz="3000" dirty="0">
-                <a:solidFill>
-                  <a:srgbClr val="000000"/>
-                </a:solidFill>
-                <a:latin typeface="Arial" panose="020B0604020202020204" pitchFamily="34" charset="0"/>
-                <a:cs typeface="Arial" panose="020B0604020202020204" pitchFamily="34" charset="0"/>
-              </a:rPr>
-              <a:t>The easiest way to show this is using a visualization for significant vs. not significant. </a:t>
-            </a:r>
-          </a:p>
-          <a:p>
-            <a:pPr marL="742950" lvl="1" indent="-285750" algn="l" rtl="0" fontAlgn="base">
-              <a:spcBef>
-                <a:spcPts val="0"/>
-              </a:spcBef>
-              <a:spcAft>
-                <a:spcPts val="0"/>
-              </a:spcAft>
-              <a:buFont typeface="Arial" panose="020B0604020202020204" pitchFamily="34" charset="0"/>
-              <a:buChar char="•"/>
-            </a:pPr>
-            <a:r>
               <a:rPr lang="en-US" sz="3000" i="0" u="none" strike="noStrike" dirty="0">
                 <a:solidFill>
                   <a:srgbClr val="000000"/>
@@ -4858,7 +4926,7 @@
                 <a:latin typeface="Arial" panose="020B0604020202020204" pitchFamily="34" charset="0"/>
                 <a:cs typeface="Arial" panose="020B0604020202020204" pitchFamily="34" charset="0"/>
               </a:rPr>
-              <a:t>The heatmap of significant values show there is a general parabolic trend in lifting capacity between age classes meaning that there is a peak in performance and then a decline where older and younger groups are not discernible</a:t>
+              <a:t>The heatmap of significant values show there is a general parabolic trend in lifting capacity between age classes meaning that there is a peak in performance and then a decline where older and younger groups are not discernible.</a:t>
             </a:r>
             <a:endParaRPr lang="en-US" sz="3000" i="0" u="none" strike="noStrike" dirty="0">
               <a:solidFill>
@@ -4886,8 +4954,8 @@
         </p:nvSpPr>
         <p:spPr bwMode="auto">
           <a:xfrm>
-            <a:off x="1600048" y="29493865"/>
-            <a:ext cx="13656134" cy="401408"/>
+            <a:off x="7206661" y="27405807"/>
+            <a:ext cx="6762291" cy="401408"/>
           </a:xfrm>
           <a:prstGeom prst="rect">
             <a:avLst/>
@@ -5025,7 +5093,7 @@
                 <a:latin typeface="Arial" panose="020B0604020202020204" pitchFamily="34" charset="0"/>
                 <a:cs typeface="Arial" panose="020B0604020202020204" pitchFamily="34" charset="0"/>
               </a:rPr>
-              <a:t>Figure 1. Dunn’s Test Results Visualization</a:t>
+              <a:t>Figure 2. Dunn’s Test Results Visualization</a:t>
             </a:r>
             <a:endParaRPr lang="en-CA" sz="2100" b="1" dirty="0">
               <a:latin typeface="Arial" panose="020B0604020202020204" pitchFamily="34" charset="0"/>
@@ -5050,7 +5118,7 @@
         </p:nvSpPr>
         <p:spPr bwMode="auto">
           <a:xfrm>
-            <a:off x="28132877" y="29788251"/>
+            <a:off x="28733474" y="25365123"/>
             <a:ext cx="13713008" cy="401408"/>
           </a:xfrm>
           <a:prstGeom prst="rect">
@@ -5189,7 +5257,7 @@
                 <a:latin typeface="Arial" panose="020B0604020202020204" pitchFamily="34" charset="0"/>
                 <a:cs typeface="Arial" panose="020B0604020202020204" pitchFamily="34" charset="0"/>
               </a:rPr>
-              <a:t>Figure 2. Visualization of Goal Achievement by Split Time</a:t>
+              <a:t>Figure 3. Visualization of Distance from Goal Achieved</a:t>
             </a:r>
             <a:endParaRPr lang="en-CA" sz="2100" b="1" dirty="0">
               <a:latin typeface="Arial" panose="020B0604020202020204" pitchFamily="34" charset="0"/>
@@ -5298,8 +5366,8 @@
         </p:nvSpPr>
         <p:spPr>
           <a:xfrm>
-            <a:off x="322307" y="17044069"/>
-            <a:ext cx="13751514" cy="923330"/>
+            <a:off x="324262" y="17405334"/>
+            <a:ext cx="13751514" cy="830997"/>
           </a:xfrm>
           <a:prstGeom prst="rect">
             <a:avLst/>
@@ -5316,11 +5384,11 @@
           <a:p>
             <a:pPr algn="ctr" eaLnBrk="1" hangingPunct="1"/>
             <a:r>
-              <a:rPr lang="en-US" sz="5400" b="1" dirty="0">
+              <a:rPr lang="en-US" sz="4800" b="1" dirty="0">
                 <a:latin typeface="Arial" panose="020B0604020202020204" pitchFamily="34" charset="0"/>
                 <a:cs typeface="Arial" panose="020B0604020202020204" pitchFamily="34" charset="0"/>
               </a:rPr>
-              <a:t>Dunn’s Test and Visualization</a:t>
+              <a:t>Dunn’s Multiple Comparison Test</a:t>
             </a:r>
           </a:p>
         </p:txBody>
@@ -5339,50 +5407,25 @@
           </p:cNvPicPr>
           <p:nvPr/>
         </p:nvPicPr>
-        <p:blipFill>
-          <a:blip r:embed="rId2"/>
-          <a:stretch>
-            <a:fillRect/>
-          </a:stretch>
+        <p:blipFill rotWithShape="1">
+          <a:blip r:embed="rId3"/>
+          <a:srcRect t="39263" b="39772"/>
+          <a:stretch/>
         </p:blipFill>
         <p:spPr>
           <a:xfrm>
-            <a:off x="283573" y="-1925176"/>
-            <a:ext cx="7511177" cy="9720347"/>
+            <a:off x="663668" y="1529030"/>
+            <a:ext cx="7511177" cy="2037902"/>
           </a:xfrm>
           <a:prstGeom prst="rect">
             <a:avLst/>
           </a:prstGeom>
-        </p:spPr>
-      </p:pic>
-      <p:pic>
-        <p:nvPicPr>
-          <p:cNvPr id="16" name="Picture 15">
-            <a:extLst>
-              <a:ext uri="{FF2B5EF4-FFF2-40B4-BE49-F238E27FC236}">
-                <a16:creationId xmlns:a16="http://schemas.microsoft.com/office/drawing/2014/main" id="{AD7A72A7-E565-E4C3-4F61-F6D3BB4DFBD5}"/>
-              </a:ext>
-            </a:extLst>
-          </p:cNvPr>
-          <p:cNvPicPr>
-            <a:picLocks noChangeAspect="1"/>
-          </p:cNvPicPr>
-          <p:nvPr/>
-        </p:nvPicPr>
-        <p:blipFill>
-          <a:blip r:embed="rId2"/>
-          <a:stretch>
-            <a:fillRect/>
-          </a:stretch>
-        </p:blipFill>
-        <p:spPr>
-          <a:xfrm>
-            <a:off x="34989381" y="-1853901"/>
-            <a:ext cx="7511177" cy="9720347"/>
-          </a:xfrm>
-          <a:prstGeom prst="rect">
-            <a:avLst/>
-          </a:prstGeom>
+          <a:noFill/>
+          <a:ln>
+            <a:solidFill>
+              <a:schemeClr val="accent1"/>
+            </a:solidFill>
+          </a:ln>
         </p:spPr>
       </p:pic>
       <p:pic>
@@ -5391,42 +5434,6 @@
             <a:extLst>
               <a:ext uri="{FF2B5EF4-FFF2-40B4-BE49-F238E27FC236}">
                 <a16:creationId xmlns:a16="http://schemas.microsoft.com/office/drawing/2014/main" id="{B3555E66-24E9-56BF-0EE5-A3F23CA32777}"/>
-              </a:ext>
-            </a:extLst>
-          </p:cNvPr>
-          <p:cNvPicPr>
-            <a:picLocks noChangeAspect="1"/>
-          </p:cNvPicPr>
-          <p:nvPr/>
-        </p:nvPicPr>
-        <p:blipFill>
-          <a:blip r:embed="rId3">
-            <a:extLst>
-              <a:ext uri="{28A0092B-C50C-407E-A947-70E740481C1C}">
-                <a14:useLocalDpi xmlns:a14="http://schemas.microsoft.com/office/drawing/2010/main" val="0"/>
-              </a:ext>
-            </a:extLst>
-          </a:blip>
-          <a:stretch>
-            <a:fillRect/>
-          </a:stretch>
-        </p:blipFill>
-        <p:spPr>
-          <a:xfrm>
-            <a:off x="3902022" y="22412795"/>
-            <a:ext cx="9974116" cy="7056784"/>
-          </a:xfrm>
-          <a:prstGeom prst="rect">
-            <a:avLst/>
-          </a:prstGeom>
-        </p:spPr>
-      </p:pic>
-      <p:pic>
-        <p:nvPicPr>
-          <p:cNvPr id="34" name="Picture 33">
-            <a:extLst>
-              <a:ext uri="{FF2B5EF4-FFF2-40B4-BE49-F238E27FC236}">
-                <a16:creationId xmlns:a16="http://schemas.microsoft.com/office/drawing/2014/main" id="{E775E83E-5044-91E4-9222-29FAB91ADB4A}"/>
               </a:ext>
             </a:extLst>
           </p:cNvPr>
@@ -5449,8 +5456,8 @@
         </p:blipFill>
         <p:spPr>
           <a:xfrm>
-            <a:off x="29853156" y="21277598"/>
-            <a:ext cx="12029025" cy="8510654"/>
+            <a:off x="7104368" y="22268779"/>
+            <a:ext cx="7153871" cy="5061433"/>
           </a:xfrm>
           <a:prstGeom prst="rect">
             <a:avLst/>
@@ -5472,7 +5479,7 @@
         <p:spPr>
           <a:xfrm>
             <a:off x="305983" y="9837642"/>
-            <a:ext cx="13767838" cy="923330"/>
+            <a:ext cx="13767838" cy="830997"/>
           </a:xfrm>
           <a:prstGeom prst="rect">
             <a:avLst/>
@@ -5489,7 +5496,7 @@
           <a:p>
             <a:pPr algn="ctr" eaLnBrk="1" hangingPunct="1"/>
             <a:r>
-              <a:rPr lang="en-US" sz="5400" b="1" dirty="0">
+              <a:rPr lang="en-US" sz="4800" b="1" dirty="0">
                 <a:latin typeface="Arial" panose="020B0604020202020204" pitchFamily="34" charset="0"/>
                 <a:cs typeface="Arial" panose="020B0604020202020204" pitchFamily="34" charset="0"/>
               </a:rPr>
@@ -5498,12 +5505,694 @@
           </a:p>
         </p:txBody>
       </p:sp>
-      <p:sp>
-        <p:nvSpPr>
-          <p:cNvPr id="36" name="Rectangle 35">
+      <mc:AlternateContent xmlns:mc="http://schemas.openxmlformats.org/markup-compatibility/2006">
+        <mc:Choice xmlns:a14="http://schemas.microsoft.com/office/drawing/2010/main" Requires="a14">
+          <p:sp>
+            <p:nvSpPr>
+              <p:cNvPr id="36" name="Rectangle 35">
+                <a:extLst>
+                  <a:ext uri="{FF2B5EF4-FFF2-40B4-BE49-F238E27FC236}">
+                    <a16:creationId xmlns:a16="http://schemas.microsoft.com/office/drawing/2014/main" id="{7A399FE9-9C13-5581-3A68-117C7DB0B219}"/>
+                  </a:ext>
+                </a:extLst>
+              </p:cNvPr>
+              <p:cNvSpPr/>
+              <p:nvPr/>
+            </p:nvSpPr>
+            <p:spPr>
+              <a:xfrm>
+                <a:off x="378594" y="10662030"/>
+                <a:ext cx="13656134" cy="6401120"/>
+              </a:xfrm>
+              <a:prstGeom prst="rect">
+                <a:avLst/>
+              </a:prstGeom>
+              <a:solidFill>
+                <a:schemeClr val="bg1"/>
+              </a:solidFill>
+              <a:ln>
+                <a:noFill/>
+              </a:ln>
+            </p:spPr>
+            <p:style>
+              <a:lnRef idx="2">
+                <a:schemeClr val="dk1"/>
+              </a:lnRef>
+              <a:fillRef idx="1">
+                <a:schemeClr val="lt1"/>
+              </a:fillRef>
+              <a:effectRef idx="0">
+                <a:schemeClr val="dk1"/>
+              </a:effectRef>
+              <a:fontRef idx="minor">
+                <a:schemeClr val="dk1"/>
+              </a:fontRef>
+            </p:style>
+            <p:txBody>
+              <a:bodyPr rtlCol="0" anchor="ctr"/>
+              <a:lstStyle/>
+              <a:p>
+                <a:pPr algn="l" rtl="0" fontAlgn="base">
+                  <a:spcBef>
+                    <a:spcPts val="0"/>
+                  </a:spcBef>
+                  <a:spcAft>
+                    <a:spcPts val="0"/>
+                  </a:spcAft>
+                </a:pPr>
+                <a:endParaRPr lang="en-US" sz="2800" b="0" i="0" u="none" strike="noStrike" dirty="0">
+                  <a:solidFill>
+                    <a:srgbClr val="000000"/>
+                  </a:solidFill>
+                  <a:effectLst/>
+                  <a:latin typeface="Arial" panose="020B0604020202020204" pitchFamily="34" charset="0"/>
+                  <a:ea typeface="Lato" panose="020F0502020204030203" pitchFamily="34" charset="0"/>
+                  <a:cs typeface="Arial" panose="020B0604020202020204" pitchFamily="34" charset="0"/>
+                </a:endParaRPr>
+              </a:p>
+              <a:p>
+                <a:pPr marL="457200" indent="-457200" algn="l" rtl="0" fontAlgn="base">
+                  <a:spcBef>
+                    <a:spcPts val="0"/>
+                  </a:spcBef>
+                  <a:spcAft>
+                    <a:spcPts val="0"/>
+                  </a:spcAft>
+                  <a:buFont typeface="Arial" panose="020B0604020202020204" pitchFamily="34" charset="0"/>
+                  <a:buChar char="•"/>
+                </a:pPr>
+                <a:r>
+                  <a:rPr lang="en-US" sz="3000" dirty="0">
+                    <a:solidFill>
+                      <a:srgbClr val="000000"/>
+                    </a:solidFill>
+                    <a:latin typeface="Arial" panose="020B0604020202020204" pitchFamily="34" charset="0"/>
+                    <a:ea typeface="Lato" panose="020F0502020204030203" pitchFamily="34" charset="0"/>
+                    <a:cs typeface="Arial" panose="020B0604020202020204" pitchFamily="34" charset="0"/>
+                  </a:rPr>
+                  <a:t>The Kruskal-Wallis test is a nonparametric analysis of variance that determines if groups are statistically discernible. </a:t>
+                </a:r>
+              </a:p>
+              <a:p>
+                <a:pPr marL="457200" indent="-457200" algn="l" rtl="0" fontAlgn="base">
+                  <a:spcBef>
+                    <a:spcPts val="0"/>
+                  </a:spcBef>
+                  <a:spcAft>
+                    <a:spcPts val="0"/>
+                  </a:spcAft>
+                  <a:buFont typeface="Arial" panose="020B0604020202020204" pitchFamily="34" charset="0"/>
+                  <a:buChar char="•"/>
+                </a:pPr>
+                <a:r>
+                  <a:rPr lang="en-US" sz="3000" b="0" i="0" u="none" strike="noStrike" dirty="0">
+                    <a:solidFill>
+                      <a:srgbClr val="000000"/>
+                    </a:solidFill>
+                    <a:effectLst/>
+                    <a:latin typeface="Arial" panose="020B0604020202020204" pitchFamily="34" charset="0"/>
+                    <a:ea typeface="Lato" panose="020F0502020204030203" pitchFamily="34" charset="0"/>
+                    <a:cs typeface="Arial" panose="020B0604020202020204" pitchFamily="34" charset="0"/>
+                  </a:rPr>
+                  <a:t>The hypotheses for testing are similar to those of ANOVA testing.</a:t>
+                </a:r>
+              </a:p>
+              <a:p>
+                <a:pPr marL="457200" indent="-457200" algn="l" rtl="0" fontAlgn="base">
+                  <a:spcBef>
+                    <a:spcPts val="0"/>
+                  </a:spcBef>
+                  <a:spcAft>
+                    <a:spcPts val="0"/>
+                  </a:spcAft>
+                  <a:buFont typeface="Arial" panose="020B0604020202020204" pitchFamily="34" charset="0"/>
+                  <a:buChar char="•"/>
+                </a:pPr>
+                <a:endParaRPr lang="en-US" sz="3000" i="1" dirty="0">
+                  <a:solidFill>
+                    <a:srgbClr val="000000"/>
+                  </a:solidFill>
+                  <a:latin typeface="Cambria Math" panose="02040503050406030204" pitchFamily="18" charset="0"/>
+                  <a:ea typeface="Lato" panose="020F0502020204030203" pitchFamily="34" charset="0"/>
+                  <a:cs typeface="Arial" panose="020B0604020202020204" pitchFamily="34" charset="0"/>
+                </a:endParaRPr>
+              </a:p>
+              <a:p>
+                <a:pPr algn="l" rtl="0" fontAlgn="base">
+                  <a:spcBef>
+                    <a:spcPts val="0"/>
+                  </a:spcBef>
+                  <a:spcAft>
+                    <a:spcPts val="0"/>
+                  </a:spcAft>
+                </a:pPr>
+                <a:endParaRPr lang="en-US" sz="3000" i="1" dirty="0">
+                  <a:solidFill>
+                    <a:srgbClr val="000000"/>
+                  </a:solidFill>
+                  <a:latin typeface="Cambria Math" panose="02040503050406030204" pitchFamily="18" charset="0"/>
+                  <a:ea typeface="Lato" panose="020F0502020204030203" pitchFamily="34" charset="0"/>
+                  <a:cs typeface="Arial" panose="020B0604020202020204" pitchFamily="34" charset="0"/>
+                </a:endParaRPr>
+              </a:p>
+              <a:p>
+                <a:pPr algn="l" rtl="0" fontAlgn="base">
+                  <a:spcBef>
+                    <a:spcPts val="0"/>
+                  </a:spcBef>
+                  <a:spcAft>
+                    <a:spcPts val="0"/>
+                  </a:spcAft>
+                </a:pPr>
+                <a:endParaRPr lang="en-US" sz="3000" i="1" dirty="0">
+                  <a:solidFill>
+                    <a:srgbClr val="000000"/>
+                  </a:solidFill>
+                  <a:latin typeface="Cambria Math" panose="02040503050406030204" pitchFamily="18" charset="0"/>
+                  <a:ea typeface="Lato" panose="020F0502020204030203" pitchFamily="34" charset="0"/>
+                  <a:cs typeface="Arial" panose="020B0604020202020204" pitchFamily="34" charset="0"/>
+                </a:endParaRPr>
+              </a:p>
+              <a:p>
+                <a:pPr algn="l" rtl="0" fontAlgn="base">
+                  <a:spcBef>
+                    <a:spcPts val="0"/>
+                  </a:spcBef>
+                  <a:spcAft>
+                    <a:spcPts val="0"/>
+                  </a:spcAft>
+                </a:pPr>
+                <a:endParaRPr lang="en-US" sz="3000" i="1" dirty="0">
+                  <a:solidFill>
+                    <a:srgbClr val="000000"/>
+                  </a:solidFill>
+                  <a:latin typeface="Cambria Math" panose="02040503050406030204" pitchFamily="18" charset="0"/>
+                  <a:ea typeface="Lato" panose="020F0502020204030203" pitchFamily="34" charset="0"/>
+                  <a:cs typeface="Arial" panose="020B0604020202020204" pitchFamily="34" charset="0"/>
+                </a:endParaRPr>
+              </a:p>
+              <a:p>
+                <a:pPr marL="457200" indent="-457200" algn="l" rtl="0" fontAlgn="base">
+                  <a:spcBef>
+                    <a:spcPts val="0"/>
+                  </a:spcBef>
+                  <a:spcAft>
+                    <a:spcPts val="0"/>
+                  </a:spcAft>
+                  <a:buFont typeface="Arial" panose="020B0604020202020204" pitchFamily="34" charset="0"/>
+                  <a:buChar char="•"/>
+                </a:pPr>
+                <a:r>
+                  <a:rPr lang="en-US" sz="3000" b="0" u="none" strike="noStrike" dirty="0">
+                    <a:solidFill>
+                      <a:srgbClr val="000000"/>
+                    </a:solidFill>
+                    <a:effectLst/>
+                    <a:ea typeface="Lato" panose="020F0502020204030203" pitchFamily="34" charset="0"/>
+                    <a:cs typeface="Arial" panose="020B0604020202020204" pitchFamily="34" charset="0"/>
+                  </a:rPr>
+                  <a:t>The test statistic is</a:t>
+                </a:r>
+                <a:r>
+                  <a:rPr lang="en-US" sz="3600" b="0" u="none" strike="noStrike" dirty="0">
+                    <a:solidFill>
+                      <a:srgbClr val="000000"/>
+                    </a:solidFill>
+                    <a:effectLst/>
+                    <a:ea typeface="Lato" panose="020F0502020204030203" pitchFamily="34" charset="0"/>
+                    <a:cs typeface="Arial" panose="020B0604020202020204" pitchFamily="34" charset="0"/>
+                  </a:rPr>
+                  <a:t>:     </a:t>
+                </a:r>
+              </a:p>
+              <a:p>
+                <a:pPr marL="457200" indent="-457200" algn="l" rtl="0" fontAlgn="base">
+                  <a:spcBef>
+                    <a:spcPts val="0"/>
+                  </a:spcBef>
+                  <a:spcAft>
+                    <a:spcPts val="0"/>
+                  </a:spcAft>
+                  <a:buFont typeface="Arial" panose="020B0604020202020204" pitchFamily="34" charset="0"/>
+                  <a:buChar char="•"/>
+                </a:pPr>
+                <a:endParaRPr lang="en-US" sz="3600" b="0" u="none" strike="noStrike" dirty="0">
+                  <a:solidFill>
+                    <a:srgbClr val="000000"/>
+                  </a:solidFill>
+                  <a:effectLst/>
+                  <a:ea typeface="Lato" panose="020F0502020204030203" pitchFamily="34" charset="0"/>
+                  <a:cs typeface="Arial" panose="020B0604020202020204" pitchFamily="34" charset="0"/>
+                </a:endParaRPr>
+              </a:p>
+              <a:p>
+                <a:pPr algn="l" rtl="0" fontAlgn="base">
+                  <a:spcBef>
+                    <a:spcPts val="0"/>
+                  </a:spcBef>
+                  <a:spcAft>
+                    <a:spcPts val="0"/>
+                  </a:spcAft>
+                </a:pPr>
+                <a:r>
+                  <a:rPr lang="en-US" sz="3600" b="0" u="none" strike="noStrike" dirty="0">
+                    <a:solidFill>
+                      <a:srgbClr val="000000"/>
+                    </a:solidFill>
+                    <a:effectLst/>
+                    <a:ea typeface="Lato" panose="020F0502020204030203" pitchFamily="34" charset="0"/>
+                    <a:cs typeface="Arial" panose="020B0604020202020204" pitchFamily="34" charset="0"/>
+                  </a:rPr>
+                  <a:t>		                                       </a:t>
+                </a:r>
+                <a:r>
+                  <a:rPr lang="en-US" sz="3000" dirty="0">
+                    <a:solidFill>
+                      <a:srgbClr val="000000"/>
+                    </a:solidFill>
+                    <a:latin typeface="Arial" panose="020B0604020202020204" pitchFamily="34" charset="0"/>
+                    <a:ea typeface="Lato" panose="020F0502020204030203" pitchFamily="34" charset="0"/>
+                    <a:cs typeface="Arial" panose="020B0604020202020204" pitchFamily="34" charset="0"/>
+                  </a:rPr>
+                  <a:t>Where </a:t>
+                </a:r>
+                <a14:m>
+                  <m:oMath xmlns:m="http://schemas.openxmlformats.org/officeDocument/2006/math">
+                    <m:sSubSup>
+                      <m:sSubSupPr>
+                        <m:ctrlPr>
+                          <a:rPr lang="en-US" sz="3000" b="0" i="1" u="none" strike="noStrike" smtClean="0">
+                            <a:solidFill>
+                              <a:srgbClr val="000000"/>
+                            </a:solidFill>
+                            <a:effectLst/>
+                            <a:latin typeface="Cambria Math" panose="02040503050406030204" pitchFamily="18" charset="0"/>
+                            <a:ea typeface="Lato" panose="020F0502020204030203" pitchFamily="34" charset="0"/>
+                            <a:cs typeface="Arial" panose="020B0604020202020204" pitchFamily="34" charset="0"/>
+                          </a:rPr>
+                        </m:ctrlPr>
+                      </m:sSubSupPr>
+                      <m:e>
+                        <m:r>
+                          <a:rPr lang="en-US" sz="3000" b="0" i="1" u="none" strike="noStrike" smtClean="0">
+                            <a:solidFill>
+                              <a:srgbClr val="000000"/>
+                            </a:solidFill>
+                            <a:effectLst/>
+                            <a:latin typeface="Cambria Math" panose="02040503050406030204" pitchFamily="18" charset="0"/>
+                            <a:ea typeface="Lato" panose="020F0502020204030203" pitchFamily="34" charset="0"/>
+                            <a:cs typeface="Arial" panose="020B0604020202020204" pitchFamily="34" charset="0"/>
+                          </a:rPr>
+                          <m:t>𝑅</m:t>
+                        </m:r>
+                      </m:e>
+                      <m:sub>
+                        <m:r>
+                          <a:rPr lang="en-US" sz="3000" b="0" i="1" u="none" strike="noStrike" smtClean="0">
+                            <a:solidFill>
+                              <a:srgbClr val="000000"/>
+                            </a:solidFill>
+                            <a:effectLst/>
+                            <a:latin typeface="Cambria Math" panose="02040503050406030204" pitchFamily="18" charset="0"/>
+                            <a:ea typeface="Lato" panose="020F0502020204030203" pitchFamily="34" charset="0"/>
+                            <a:cs typeface="Arial" panose="020B0604020202020204" pitchFamily="34" charset="0"/>
+                          </a:rPr>
+                          <m:t>𝑖</m:t>
+                        </m:r>
+                      </m:sub>
+                      <m:sup>
+                        <m:r>
+                          <a:rPr lang="en-US" sz="3000" b="0" i="1" u="none" strike="noStrike" smtClean="0">
+                            <a:solidFill>
+                              <a:srgbClr val="000000"/>
+                            </a:solidFill>
+                            <a:effectLst/>
+                            <a:latin typeface="Cambria Math" panose="02040503050406030204" pitchFamily="18" charset="0"/>
+                            <a:ea typeface="Lato" panose="020F0502020204030203" pitchFamily="34" charset="0"/>
+                            <a:cs typeface="Arial" panose="020B0604020202020204" pitchFamily="34" charset="0"/>
+                          </a:rPr>
+                          <m:t>2</m:t>
+                        </m:r>
+                      </m:sup>
+                    </m:sSubSup>
+                  </m:oMath>
+                </a14:m>
+                <a:r>
+                  <a:rPr lang="en-US" sz="3000" b="0" i="0" u="none" strike="noStrike" dirty="0">
+                    <a:solidFill>
+                      <a:srgbClr val="000000"/>
+                    </a:solidFill>
+                    <a:effectLst/>
+                    <a:latin typeface="Arial" panose="020B0604020202020204" pitchFamily="34" charset="0"/>
+                    <a:ea typeface="Lato" panose="020F0502020204030203" pitchFamily="34" charset="0"/>
+                    <a:cs typeface="Arial" panose="020B0604020202020204" pitchFamily="34" charset="0"/>
+                  </a:rPr>
+                  <a:t> is the sum of ranks in the </a:t>
+                </a:r>
+                <a:r>
+                  <a:rPr lang="en-US" sz="3000" b="0" i="0" u="none" strike="noStrike" dirty="0" err="1">
+                    <a:solidFill>
+                      <a:srgbClr val="000000"/>
+                    </a:solidFill>
+                    <a:effectLst/>
+                    <a:latin typeface="Arial" panose="020B0604020202020204" pitchFamily="34" charset="0"/>
+                    <a:ea typeface="Lato" panose="020F0502020204030203" pitchFamily="34" charset="0"/>
+                    <a:cs typeface="Arial" panose="020B0604020202020204" pitchFamily="34" charset="0"/>
+                  </a:rPr>
+                  <a:t>i-th</a:t>
+                </a:r>
+                <a:r>
+                  <a:rPr lang="en-US" sz="3000" b="0" i="0" u="none" strike="noStrike" dirty="0">
+                    <a:solidFill>
+                      <a:srgbClr val="000000"/>
+                    </a:solidFill>
+                    <a:effectLst/>
+                    <a:latin typeface="Arial" panose="020B0604020202020204" pitchFamily="34" charset="0"/>
+                    <a:ea typeface="Lato" panose="020F0502020204030203" pitchFamily="34" charset="0"/>
+                    <a:cs typeface="Arial" panose="020B0604020202020204" pitchFamily="34" charset="0"/>
+                  </a:rPr>
+                  <a:t> group and k is the number of groups.</a:t>
+                </a:r>
+                <a:endParaRPr lang="en-US" sz="3000" dirty="0">
+                  <a:solidFill>
+                    <a:srgbClr val="000000"/>
+                  </a:solidFill>
+                  <a:latin typeface="Arial" panose="020B0604020202020204" pitchFamily="34" charset="0"/>
+                  <a:ea typeface="Lato" panose="020F0502020204030203" pitchFamily="34" charset="0"/>
+                  <a:cs typeface="Arial" panose="020B0604020202020204" pitchFamily="34" charset="0"/>
+                </a:endParaRPr>
+              </a:p>
+              <a:p>
+                <a:pPr marL="457200" indent="-457200" algn="l" rtl="0" fontAlgn="base">
+                  <a:spcBef>
+                    <a:spcPts val="0"/>
+                  </a:spcBef>
+                  <a:spcAft>
+                    <a:spcPts val="0"/>
+                  </a:spcAft>
+                  <a:buFont typeface="Arial" panose="020B0604020202020204" pitchFamily="34" charset="0"/>
+                  <a:buChar char="•"/>
+                </a:pPr>
+                <a:r>
+                  <a:rPr lang="en-US" sz="3000" b="0" i="0" u="none" strike="noStrike" dirty="0">
+                    <a:solidFill>
+                      <a:srgbClr val="000000"/>
+                    </a:solidFill>
+                    <a:effectLst/>
+                    <a:latin typeface="Arial" panose="020B0604020202020204" pitchFamily="34" charset="0"/>
+                    <a:ea typeface="Lato" panose="020F0502020204030203" pitchFamily="34" charset="0"/>
+                    <a:cs typeface="Arial" panose="020B0604020202020204" pitchFamily="34" charset="0"/>
+                  </a:rPr>
+                  <a:t>The test resulted in p-value &lt; 2.2e-16 indicating at least one group is statistically discernible from another and we should reject the null hypothesis.</a:t>
+                </a:r>
+              </a:p>
+            </p:txBody>
+          </p:sp>
+        </mc:Choice>
+        <mc:Fallback>
+          <p:sp>
+            <p:nvSpPr>
+              <p:cNvPr id="36" name="Rectangle 35">
+                <a:extLst>
+                  <a:ext uri="{FF2B5EF4-FFF2-40B4-BE49-F238E27FC236}">
+                    <a16:creationId xmlns:a16="http://schemas.microsoft.com/office/drawing/2014/main" id="{7A399FE9-9C13-5581-3A68-117C7DB0B219}"/>
+                  </a:ext>
+                </a:extLst>
+              </p:cNvPr>
+              <p:cNvSpPr>
+                <a:spLocks noRot="1" noChangeAspect="1" noMove="1" noResize="1" noEditPoints="1" noAdjustHandles="1" noChangeArrowheads="1" noChangeShapeType="1" noTextEdit="1"/>
+              </p:cNvSpPr>
+              <p:nvPr/>
+            </p:nvSpPr>
+            <p:spPr>
+              <a:xfrm>
+                <a:off x="378594" y="10662030"/>
+                <a:ext cx="13656134" cy="6401120"/>
+              </a:xfrm>
+              <a:prstGeom prst="rect">
+                <a:avLst/>
+              </a:prstGeom>
+              <a:blipFill>
+                <a:blip r:embed="rId5"/>
+                <a:stretch>
+                  <a:fillRect l="-1022" r="-836" b="-5743"/>
+                </a:stretch>
+              </a:blipFill>
+              <a:ln>
+                <a:noFill/>
+              </a:ln>
+            </p:spPr>
+            <p:txBody>
+              <a:bodyPr/>
+              <a:lstStyle/>
+              <a:p>
+                <a:r>
+                  <a:rPr lang="en-US">
+                    <a:noFill/>
+                  </a:rPr>
+                  <a:t> </a:t>
+                </a:r>
+              </a:p>
+            </p:txBody>
+          </p:sp>
+        </mc:Fallback>
+      </mc:AlternateContent>
+      <p:sp>
+        <p:nvSpPr>
+          <p:cNvPr id="43" name="Text Box 10">
             <a:extLst>
               <a:ext uri="{FF2B5EF4-FFF2-40B4-BE49-F238E27FC236}">
-                <a16:creationId xmlns:a16="http://schemas.microsoft.com/office/drawing/2014/main" id="{7A399FE9-9C13-5581-3A68-117C7DB0B219}"/>
+                <a16:creationId xmlns:a16="http://schemas.microsoft.com/office/drawing/2014/main" id="{4211B928-5237-5C09-3E3E-DA13F0B4AB76}"/>
+              </a:ext>
+            </a:extLst>
+          </p:cNvPr>
+          <p:cNvSpPr txBox="1">
+            <a:spLocks noChangeArrowheads="1"/>
+          </p:cNvSpPr>
+          <p:nvPr/>
+        </p:nvSpPr>
+        <p:spPr bwMode="auto">
+          <a:xfrm>
+            <a:off x="39551501" y="14491915"/>
+            <a:ext cx="3100909" cy="401408"/>
+          </a:xfrm>
+          <a:prstGeom prst="rect">
+            <a:avLst/>
+          </a:prstGeom>
+          <a:noFill/>
+          <a:ln>
+            <a:noFill/>
+          </a:ln>
+          <a:extLst>
+            <a:ext uri="{909E8E84-426E-40dd-AFC4-6F175D3DCCD1}">
+              <a14:hiddenFill xmlns="" xmlns:a14="http://schemas.microsoft.com/office/drawing/2010/main">
+                <a:solidFill>
+                  <a:srgbClr val="FFFFFF"/>
+                </a:solidFill>
+              </a14:hiddenFill>
+            </a:ext>
+            <a:ext uri="{91240B29-F687-4f45-9708-019B960494DF}">
+              <a14:hiddenLine xmlns="" xmlns:a14="http://schemas.microsoft.com/office/drawing/2010/main" w="9525">
+                <a:solidFill>
+                  <a:srgbClr val="000000"/>
+                </a:solidFill>
+                <a:miter lim="800000"/>
+                <a:headEnd/>
+                <a:tailEnd/>
+              </a14:hiddenLine>
+            </a:ext>
+          </a:extLst>
+        </p:spPr>
+        <p:txBody>
+          <a:bodyPr wrap="square" lIns="77486" tIns="38743" rIns="77486" bIns="38743">
+            <a:spAutoFit/>
+          </a:bodyPr>
+          <a:lstStyle>
+            <a:lvl1pPr eaLnBrk="0" hangingPunct="0">
+              <a:defRPr sz="2000">
+                <a:solidFill>
+                  <a:schemeClr val="tx1"/>
+                </a:solidFill>
+                <a:latin typeface="Times New Roman" pitchFamily="18" charset="0"/>
+              </a:defRPr>
+            </a:lvl1pPr>
+            <a:lvl2pPr marL="742950" indent="-285750" eaLnBrk="0" hangingPunct="0">
+              <a:defRPr sz="2000">
+                <a:solidFill>
+                  <a:schemeClr val="tx1"/>
+                </a:solidFill>
+                <a:latin typeface="Times New Roman" pitchFamily="18" charset="0"/>
+              </a:defRPr>
+            </a:lvl2pPr>
+            <a:lvl3pPr marL="1143000" indent="-228600" eaLnBrk="0" hangingPunct="0">
+              <a:defRPr sz="2000">
+                <a:solidFill>
+                  <a:schemeClr val="tx1"/>
+                </a:solidFill>
+                <a:latin typeface="Times New Roman" pitchFamily="18" charset="0"/>
+              </a:defRPr>
+            </a:lvl3pPr>
+            <a:lvl4pPr marL="1600200" indent="-228600" eaLnBrk="0" hangingPunct="0">
+              <a:defRPr sz="2000">
+                <a:solidFill>
+                  <a:schemeClr val="tx1"/>
+                </a:solidFill>
+                <a:latin typeface="Times New Roman" pitchFamily="18" charset="0"/>
+              </a:defRPr>
+            </a:lvl4pPr>
+            <a:lvl5pPr marL="2057400" indent="-228600" eaLnBrk="0" hangingPunct="0">
+              <a:defRPr sz="2000">
+                <a:solidFill>
+                  <a:schemeClr val="tx1"/>
+                </a:solidFill>
+                <a:latin typeface="Times New Roman" pitchFamily="18" charset="0"/>
+              </a:defRPr>
+            </a:lvl5pPr>
+            <a:lvl6pPr marL="2514600" indent="-228600" eaLnBrk="0" fontAlgn="base" hangingPunct="0">
+              <a:spcBef>
+                <a:spcPct val="0"/>
+              </a:spcBef>
+              <a:spcAft>
+                <a:spcPct val="0"/>
+              </a:spcAft>
+              <a:defRPr sz="2000">
+                <a:solidFill>
+                  <a:schemeClr val="tx1"/>
+                </a:solidFill>
+                <a:latin typeface="Times New Roman" pitchFamily="18" charset="0"/>
+              </a:defRPr>
+            </a:lvl6pPr>
+            <a:lvl7pPr marL="2971800" indent="-228600" eaLnBrk="0" fontAlgn="base" hangingPunct="0">
+              <a:spcBef>
+                <a:spcPct val="0"/>
+              </a:spcBef>
+              <a:spcAft>
+                <a:spcPct val="0"/>
+              </a:spcAft>
+              <a:defRPr sz="2000">
+                <a:solidFill>
+                  <a:schemeClr val="tx1"/>
+                </a:solidFill>
+                <a:latin typeface="Times New Roman" pitchFamily="18" charset="0"/>
+              </a:defRPr>
+            </a:lvl7pPr>
+            <a:lvl8pPr marL="3429000" indent="-228600" eaLnBrk="0" fontAlgn="base" hangingPunct="0">
+              <a:spcBef>
+                <a:spcPct val="0"/>
+              </a:spcBef>
+              <a:spcAft>
+                <a:spcPct val="0"/>
+              </a:spcAft>
+              <a:defRPr sz="2000">
+                <a:solidFill>
+                  <a:schemeClr val="tx1"/>
+                </a:solidFill>
+                <a:latin typeface="Times New Roman" pitchFamily="18" charset="0"/>
+              </a:defRPr>
+            </a:lvl8pPr>
+            <a:lvl9pPr marL="3886200" indent="-228600" eaLnBrk="0" fontAlgn="base" hangingPunct="0">
+              <a:spcBef>
+                <a:spcPct val="0"/>
+              </a:spcBef>
+              <a:spcAft>
+                <a:spcPct val="0"/>
+              </a:spcAft>
+              <a:defRPr sz="2000">
+                <a:solidFill>
+                  <a:schemeClr val="tx1"/>
+                </a:solidFill>
+                <a:latin typeface="Times New Roman" pitchFamily="18" charset="0"/>
+              </a:defRPr>
+            </a:lvl9pPr>
+          </a:lstStyle>
+          <a:p>
+            <a:pPr algn="ctr" eaLnBrk="1" hangingPunct="1"/>
+            <a:r>
+              <a:rPr lang="en-US" sz="2100" b="1" dirty="0">
+                <a:latin typeface="Arial" panose="020B0604020202020204" pitchFamily="34" charset="0"/>
+                <a:cs typeface="Arial" panose="020B0604020202020204" pitchFamily="34" charset="0"/>
+              </a:rPr>
+              <a:t>QR Code for data</a:t>
+            </a:r>
+            <a:endParaRPr lang="en-CA" sz="2100" b="1" dirty="0">
+              <a:latin typeface="Arial" panose="020B0604020202020204" pitchFamily="34" charset="0"/>
+              <a:cs typeface="Arial" panose="020B0604020202020204" pitchFamily="34" charset="0"/>
+            </a:endParaRPr>
+          </a:p>
+        </p:txBody>
+      </p:sp>
+      <p:pic>
+        <p:nvPicPr>
+          <p:cNvPr id="44" name="Picture 43">
+            <a:extLst>
+              <a:ext uri="{FF2B5EF4-FFF2-40B4-BE49-F238E27FC236}">
+                <a16:creationId xmlns:a16="http://schemas.microsoft.com/office/drawing/2014/main" id="{7F4ABE18-5A26-0D43-BE76-448B50832790}"/>
+              </a:ext>
+            </a:extLst>
+          </p:cNvPr>
+          <p:cNvPicPr>
+            <a:picLocks noChangeAspect="1"/>
+          </p:cNvPicPr>
+          <p:nvPr/>
+        </p:nvPicPr>
+        <p:blipFill>
+          <a:blip r:embed="rId6"/>
+          <a:stretch>
+            <a:fillRect/>
+          </a:stretch>
+        </p:blipFill>
+        <p:spPr>
+          <a:xfrm>
+            <a:off x="249131" y="27885403"/>
+            <a:ext cx="2443178" cy="2443178"/>
+          </a:xfrm>
+          <a:prstGeom prst="rect">
+            <a:avLst/>
+          </a:prstGeom>
+        </p:spPr>
+      </p:pic>
+      <p:pic>
+        <p:nvPicPr>
+          <p:cNvPr id="47" name="Picture 46" descr="A gold medal with red and white stripes&#10;&#10;Description automatically generated">
+            <a:extLst>
+              <a:ext uri="{FF2B5EF4-FFF2-40B4-BE49-F238E27FC236}">
+                <a16:creationId xmlns:a16="http://schemas.microsoft.com/office/drawing/2014/main" id="{9816EB6B-ED0D-41CA-BD23-D712B16C99C4}"/>
+              </a:ext>
+            </a:extLst>
+          </p:cNvPr>
+          <p:cNvPicPr>
+            <a:picLocks noChangeAspect="1"/>
+          </p:cNvPicPr>
+          <p:nvPr/>
+        </p:nvPicPr>
+        <p:blipFill>
+          <a:blip r:embed="rId7">
+            <a:extLst>
+              <a:ext uri="{28A0092B-C50C-407E-A947-70E740481C1C}">
+                <a14:useLocalDpi xmlns:a14="http://schemas.microsoft.com/office/drawing/2010/main" val="0"/>
+              </a:ext>
+            </a:extLst>
+          </a:blip>
+          <a:stretch>
+            <a:fillRect/>
+          </a:stretch>
+        </p:blipFill>
+        <p:spPr>
+          <a:xfrm>
+            <a:off x="18235278" y="10186119"/>
+            <a:ext cx="6286500" cy="3441700"/>
+          </a:xfrm>
+          <a:prstGeom prst="rect">
+            <a:avLst/>
+          </a:prstGeom>
+        </p:spPr>
+      </p:pic>
+      <p:sp>
+        <p:nvSpPr>
+          <p:cNvPr id="59" name="Rectangle 58">
+            <a:extLst>
+              <a:ext uri="{FF2B5EF4-FFF2-40B4-BE49-F238E27FC236}">
+                <a16:creationId xmlns:a16="http://schemas.microsoft.com/office/drawing/2014/main" id="{7ED2883E-0C25-9FDA-9F6D-9BA6F6C98F6A}"/>
               </a:ext>
             </a:extLst>
           </p:cNvPr>
@@ -5512,8 +6201,8 @@
         </p:nvSpPr>
         <p:spPr>
           <a:xfrm>
-            <a:off x="378594" y="12264339"/>
-            <a:ext cx="13656134" cy="4315808"/>
+            <a:off x="28558618" y="15860067"/>
+            <a:ext cx="13615376" cy="2920368"/>
           </a:xfrm>
           <a:prstGeom prst="rect">
             <a:avLst/>
@@ -5543,26 +6232,24 @@
           <a:bodyPr rtlCol="0" anchor="ctr"/>
           <a:lstStyle/>
           <a:p>
-            <a:pPr algn="l" rtl="0" fontAlgn="base">
-              <a:spcBef>
-                <a:spcPts val="0"/>
-              </a:spcBef>
-              <a:spcAft>
-                <a:spcPts val="0"/>
-              </a:spcAft>
+            <a:pPr marL="457200" indent="-457200">
+              <a:buFont typeface="Arial" panose="020B0604020202020204" pitchFamily="34" charset="0"/>
+              <a:buChar char="•"/>
             </a:pPr>
-            <a:endParaRPr lang="en-US" sz="2800" b="0" i="0" u="none" strike="noStrike" dirty="0">
-              <a:solidFill>
-                <a:srgbClr val="000000"/>
-              </a:solidFill>
-              <a:effectLst/>
-              <a:latin typeface="Arial" panose="020B0604020202020204" pitchFamily="34" charset="0"/>
-              <a:ea typeface="Lato" panose="020F0502020204030203" pitchFamily="34" charset="0"/>
-              <a:cs typeface="Arial" panose="020B0604020202020204" pitchFamily="34" charset="0"/>
-            </a:endParaRPr>
-          </a:p>
-          <a:p>
-            <a:pPr marL="457200" indent="-457200" algn="l" rtl="0" fontAlgn="base">
+            <a:r>
+              <a:rPr lang="en-US" sz="3000" b="0" i="0" u="none" strike="noStrike" dirty="0">
+                <a:solidFill>
+                  <a:srgbClr val="000000"/>
+                </a:solidFill>
+                <a:effectLst/>
+                <a:latin typeface="Arial" panose="020B0604020202020204" pitchFamily="34" charset="0"/>
+                <a:cs typeface="Arial" panose="020B0604020202020204" pitchFamily="34" charset="0"/>
+              </a:rPr>
+              <a:t>The scatterplot shows rowers’ goals compared to how far from their goal (rounded in seconds) they achieved on that piece.</a:t>
+            </a:r>
+          </a:p>
+          <a:p>
+            <a:pPr marL="457200" indent="-457200" algn="l" rtl="0">
               <a:spcBef>
                 <a:spcPts val="0"/>
               </a:spcBef>
@@ -5573,19 +6260,19 @@
               <a:buChar char="•"/>
             </a:pPr>
             <a:r>
-              <a:rPr lang="en-US" sz="3000" dirty="0">
+              <a:rPr lang="en-US" sz="3000" b="0" i="0" u="none" strike="noStrike" dirty="0">
                 <a:solidFill>
                   <a:srgbClr val="000000"/>
                 </a:solidFill>
+                <a:effectLst/>
                 <a:latin typeface="Arial" panose="020B0604020202020204" pitchFamily="34" charset="0"/>
-                <a:ea typeface="Lato" panose="020F0502020204030203" pitchFamily="34" charset="0"/>
                 <a:cs typeface="Arial" panose="020B0604020202020204" pitchFamily="34" charset="0"/>
               </a:rPr>
-              <a:t>The Kruskal-Wallis test is a nonparametric analysis of variance that determines if groups are statistically discernible. </a:t>
-            </a:r>
-          </a:p>
-          <a:p>
-            <a:pPr marL="457200" indent="-457200" algn="l" rtl="0" fontAlgn="base">
+              <a:t>The confidence interval and visualization show that many athletes are meeting or exceeding their goals during test pieces, indicating that they should reassess how ambitious their aim is.</a:t>
+            </a:r>
+          </a:p>
+          <a:p>
+            <a:pPr marL="457200" indent="-457200" algn="l" rtl="0">
               <a:spcBef>
                 <a:spcPts val="0"/>
               </a:spcBef>
@@ -5598,310 +6285,41 @@
             <a:r>
               <a:rPr lang="en-US" sz="3000" b="0" i="0" u="none" strike="noStrike" dirty="0">
                 <a:solidFill>
-                  <a:srgbClr val="000000"/>
+                  <a:schemeClr val="tx1"/>
                 </a:solidFill>
                 <a:effectLst/>
                 <a:latin typeface="Arial" panose="020B0604020202020204" pitchFamily="34" charset="0"/>
-                <a:ea typeface="Lato" panose="020F0502020204030203" pitchFamily="34" charset="0"/>
                 <a:cs typeface="Arial" panose="020B0604020202020204" pitchFamily="34" charset="0"/>
               </a:rPr>
-              <a:t>The hypotheses for testing are similar to those of ANOVA testing.</a:t>
-            </a:r>
-          </a:p>
-          <a:p>
-            <a:pPr marL="457200" indent="-457200" algn="l" rtl="0" fontAlgn="base">
-              <a:spcBef>
-                <a:spcPts val="0"/>
-              </a:spcBef>
-              <a:spcAft>
-                <a:spcPts val="0"/>
-              </a:spcAft>
-              <a:buFont typeface="Arial" panose="020B0604020202020204" pitchFamily="34" charset="0"/>
-              <a:buChar char="•"/>
-            </a:pPr>
-            <a:endParaRPr lang="en-US" sz="3000" dirty="0">
-              <a:solidFill>
-                <a:srgbClr val="000000"/>
-              </a:solidFill>
-              <a:latin typeface="Arial" panose="020B0604020202020204" pitchFamily="34" charset="0"/>
-              <a:ea typeface="Lato" panose="020F0502020204030203" pitchFamily="34" charset="0"/>
-              <a:cs typeface="Arial" panose="020B0604020202020204" pitchFamily="34" charset="0"/>
-            </a:endParaRPr>
-          </a:p>
-          <a:p>
-            <a:pPr marL="457200" indent="-457200" algn="l" rtl="0" fontAlgn="base">
-              <a:spcBef>
-                <a:spcPts val="0"/>
-              </a:spcBef>
-              <a:spcAft>
-                <a:spcPts val="0"/>
-              </a:spcAft>
-              <a:buFont typeface="Arial" panose="020B0604020202020204" pitchFamily="34" charset="0"/>
-              <a:buChar char="•"/>
-            </a:pPr>
+              <a:t>We can extend this module to explore more about the </a:t>
+            </a:r>
+            <a:r>
+              <a:rPr lang="en-US" sz="3000" dirty="0">
+                <a:solidFill>
+                  <a:schemeClr val="tx1"/>
+                </a:solidFill>
+                <a:latin typeface="Arial" panose="020B0604020202020204" pitchFamily="34" charset="0"/>
+                <a:cs typeface="Arial" panose="020B0604020202020204" pitchFamily="34" charset="0"/>
+              </a:rPr>
+              <a:t>type of goal being set.</a:t>
+            </a:r>
             <a:endParaRPr lang="en-US" sz="3000" b="0" i="0" u="none" strike="noStrike" dirty="0">
               <a:solidFill>
-                <a:srgbClr val="000000"/>
+                <a:schemeClr val="tx1"/>
               </a:solidFill>
               <a:effectLst/>
               <a:latin typeface="Arial" panose="020B0604020202020204" pitchFamily="34" charset="0"/>
-              <a:ea typeface="Lato" panose="020F0502020204030203" pitchFamily="34" charset="0"/>
               <a:cs typeface="Arial" panose="020B0604020202020204" pitchFamily="34" charset="0"/>
             </a:endParaRPr>
           </a:p>
-          <a:p>
-            <a:pPr marL="457200" indent="-457200" algn="l" rtl="0" fontAlgn="base">
-              <a:spcBef>
-                <a:spcPts val="0"/>
-              </a:spcBef>
-              <a:spcAft>
-                <a:spcPts val="0"/>
-              </a:spcAft>
-              <a:buFont typeface="Arial" panose="020B0604020202020204" pitchFamily="34" charset="0"/>
-              <a:buChar char="•"/>
-            </a:pPr>
-            <a:endParaRPr lang="en-US" sz="3000" b="0" i="0" u="none" strike="noStrike" dirty="0">
-              <a:solidFill>
-                <a:srgbClr val="000000"/>
-              </a:solidFill>
-              <a:effectLst/>
-              <a:latin typeface="Arial" panose="020B0604020202020204" pitchFamily="34" charset="0"/>
-              <a:ea typeface="Lato" panose="020F0502020204030203" pitchFamily="34" charset="0"/>
-              <a:cs typeface="Arial" panose="020B0604020202020204" pitchFamily="34" charset="0"/>
-            </a:endParaRPr>
-          </a:p>
-          <a:p>
-            <a:pPr algn="l" rtl="0" fontAlgn="base">
-              <a:spcBef>
-                <a:spcPts val="0"/>
-              </a:spcBef>
-              <a:spcAft>
-                <a:spcPts val="0"/>
-              </a:spcAft>
-            </a:pPr>
-            <a:endParaRPr lang="en-US" sz="3000" dirty="0">
-              <a:solidFill>
-                <a:srgbClr val="000000"/>
-              </a:solidFill>
-              <a:latin typeface="Arial" panose="020B0604020202020204" pitchFamily="34" charset="0"/>
-              <a:ea typeface="Lato" panose="020F0502020204030203" pitchFamily="34" charset="0"/>
-              <a:cs typeface="Arial" panose="020B0604020202020204" pitchFamily="34" charset="0"/>
-            </a:endParaRPr>
-          </a:p>
-          <a:p>
-            <a:pPr marL="457200" indent="-457200" algn="l" rtl="0" fontAlgn="base">
-              <a:spcBef>
-                <a:spcPts val="0"/>
-              </a:spcBef>
-              <a:spcAft>
-                <a:spcPts val="0"/>
-              </a:spcAft>
-              <a:buFont typeface="Arial" panose="020B0604020202020204" pitchFamily="34" charset="0"/>
-              <a:buChar char="•"/>
-            </a:pPr>
-            <a:r>
-              <a:rPr lang="en-US" sz="3000" b="0" i="0" u="none" strike="noStrike" dirty="0">
-                <a:solidFill>
-                  <a:srgbClr val="000000"/>
-                </a:solidFill>
-                <a:effectLst/>
-                <a:latin typeface="Arial" panose="020B0604020202020204" pitchFamily="34" charset="0"/>
-                <a:ea typeface="Lato" panose="020F0502020204030203" pitchFamily="34" charset="0"/>
-                <a:cs typeface="Arial" panose="020B0604020202020204" pitchFamily="34" charset="0"/>
-              </a:rPr>
-              <a:t>The test resulted in p-value &lt; 2.2e-16 indicating at least one group is statistically discernible from another and we should reject the null hypothesis.</a:t>
-            </a:r>
-          </a:p>
-          <a:p>
-            <a:pPr algn="l" rtl="0" fontAlgn="base">
-              <a:spcBef>
-                <a:spcPts val="0"/>
-              </a:spcBef>
-              <a:spcAft>
-                <a:spcPts val="0"/>
-              </a:spcAft>
-            </a:pPr>
-            <a:endParaRPr lang="en-US" sz="1200" dirty="0">
-              <a:solidFill>
-                <a:srgbClr val="000000"/>
-              </a:solidFill>
-              <a:latin typeface="Arial" panose="020B0604020202020204" pitchFamily="34" charset="0"/>
-              <a:ea typeface="Lato" panose="020F0502020204030203" pitchFamily="34" charset="0"/>
-              <a:cs typeface="Arial" panose="020B0604020202020204" pitchFamily="34" charset="0"/>
-            </a:endParaRPr>
-          </a:p>
-        </p:txBody>
-      </p:sp>
-      <p:sp>
-        <p:nvSpPr>
-          <p:cNvPr id="43" name="Text Box 10">
+        </p:txBody>
+      </p:sp>
+      <p:pic>
+        <p:nvPicPr>
+          <p:cNvPr id="41" name="Picture 40">
             <a:extLst>
               <a:ext uri="{FF2B5EF4-FFF2-40B4-BE49-F238E27FC236}">
-                <a16:creationId xmlns:a16="http://schemas.microsoft.com/office/drawing/2014/main" id="{4211B928-5237-5C09-3E3E-DA13F0B4AB76}"/>
-              </a:ext>
-            </a:extLst>
-          </p:cNvPr>
-          <p:cNvSpPr txBox="1">
-            <a:spLocks noChangeArrowheads="1"/>
-          </p:cNvSpPr>
-          <p:nvPr/>
-        </p:nvSpPr>
-        <p:spPr bwMode="auto">
-          <a:xfrm>
-            <a:off x="38866128" y="16785776"/>
-            <a:ext cx="3100909" cy="401408"/>
-          </a:xfrm>
-          <a:prstGeom prst="rect">
-            <a:avLst/>
-          </a:prstGeom>
-          <a:noFill/>
-          <a:ln>
-            <a:noFill/>
-          </a:ln>
-          <a:extLst>
-            <a:ext uri="{909E8E84-426E-40dd-AFC4-6F175D3DCCD1}">
-              <a14:hiddenFill xmlns="" xmlns:a14="http://schemas.microsoft.com/office/drawing/2010/main">
-                <a:solidFill>
-                  <a:srgbClr val="FFFFFF"/>
-                </a:solidFill>
-              </a14:hiddenFill>
-            </a:ext>
-            <a:ext uri="{91240B29-F687-4f45-9708-019B960494DF}">
-              <a14:hiddenLine xmlns="" xmlns:a14="http://schemas.microsoft.com/office/drawing/2010/main" w="9525">
-                <a:solidFill>
-                  <a:srgbClr val="000000"/>
-                </a:solidFill>
-                <a:miter lim="800000"/>
-                <a:headEnd/>
-                <a:tailEnd/>
-              </a14:hiddenLine>
-            </a:ext>
-          </a:extLst>
-        </p:spPr>
-        <p:txBody>
-          <a:bodyPr wrap="square" lIns="77486" tIns="38743" rIns="77486" bIns="38743">
-            <a:spAutoFit/>
-          </a:bodyPr>
-          <a:lstStyle>
-            <a:lvl1pPr eaLnBrk="0" hangingPunct="0">
-              <a:defRPr sz="2000">
-                <a:solidFill>
-                  <a:schemeClr val="tx1"/>
-                </a:solidFill>
-                <a:latin typeface="Times New Roman" pitchFamily="18" charset="0"/>
-              </a:defRPr>
-            </a:lvl1pPr>
-            <a:lvl2pPr marL="742950" indent="-285750" eaLnBrk="0" hangingPunct="0">
-              <a:defRPr sz="2000">
-                <a:solidFill>
-                  <a:schemeClr val="tx1"/>
-                </a:solidFill>
-                <a:latin typeface="Times New Roman" pitchFamily="18" charset="0"/>
-              </a:defRPr>
-            </a:lvl2pPr>
-            <a:lvl3pPr marL="1143000" indent="-228600" eaLnBrk="0" hangingPunct="0">
-              <a:defRPr sz="2000">
-                <a:solidFill>
-                  <a:schemeClr val="tx1"/>
-                </a:solidFill>
-                <a:latin typeface="Times New Roman" pitchFamily="18" charset="0"/>
-              </a:defRPr>
-            </a:lvl3pPr>
-            <a:lvl4pPr marL="1600200" indent="-228600" eaLnBrk="0" hangingPunct="0">
-              <a:defRPr sz="2000">
-                <a:solidFill>
-                  <a:schemeClr val="tx1"/>
-                </a:solidFill>
-                <a:latin typeface="Times New Roman" pitchFamily="18" charset="0"/>
-              </a:defRPr>
-            </a:lvl4pPr>
-            <a:lvl5pPr marL="2057400" indent="-228600" eaLnBrk="0" hangingPunct="0">
-              <a:defRPr sz="2000">
-                <a:solidFill>
-                  <a:schemeClr val="tx1"/>
-                </a:solidFill>
-                <a:latin typeface="Times New Roman" pitchFamily="18" charset="0"/>
-              </a:defRPr>
-            </a:lvl5pPr>
-            <a:lvl6pPr marL="2514600" indent="-228600" eaLnBrk="0" fontAlgn="base" hangingPunct="0">
-              <a:spcBef>
-                <a:spcPct val="0"/>
-              </a:spcBef>
-              <a:spcAft>
-                <a:spcPct val="0"/>
-              </a:spcAft>
-              <a:defRPr sz="2000">
-                <a:solidFill>
-                  <a:schemeClr val="tx1"/>
-                </a:solidFill>
-                <a:latin typeface="Times New Roman" pitchFamily="18" charset="0"/>
-              </a:defRPr>
-            </a:lvl6pPr>
-            <a:lvl7pPr marL="2971800" indent="-228600" eaLnBrk="0" fontAlgn="base" hangingPunct="0">
-              <a:spcBef>
-                <a:spcPct val="0"/>
-              </a:spcBef>
-              <a:spcAft>
-                <a:spcPct val="0"/>
-              </a:spcAft>
-              <a:defRPr sz="2000">
-                <a:solidFill>
-                  <a:schemeClr val="tx1"/>
-                </a:solidFill>
-                <a:latin typeface="Times New Roman" pitchFamily="18" charset="0"/>
-              </a:defRPr>
-            </a:lvl7pPr>
-            <a:lvl8pPr marL="3429000" indent="-228600" eaLnBrk="0" fontAlgn="base" hangingPunct="0">
-              <a:spcBef>
-                <a:spcPct val="0"/>
-              </a:spcBef>
-              <a:spcAft>
-                <a:spcPct val="0"/>
-              </a:spcAft>
-              <a:defRPr sz="2000">
-                <a:solidFill>
-                  <a:schemeClr val="tx1"/>
-                </a:solidFill>
-                <a:latin typeface="Times New Roman" pitchFamily="18" charset="0"/>
-              </a:defRPr>
-            </a:lvl8pPr>
-            <a:lvl9pPr marL="3886200" indent="-228600" eaLnBrk="0" fontAlgn="base" hangingPunct="0">
-              <a:spcBef>
-                <a:spcPct val="0"/>
-              </a:spcBef>
-              <a:spcAft>
-                <a:spcPct val="0"/>
-              </a:spcAft>
-              <a:defRPr sz="2000">
-                <a:solidFill>
-                  <a:schemeClr val="tx1"/>
-                </a:solidFill>
-                <a:latin typeface="Times New Roman" pitchFamily="18" charset="0"/>
-              </a:defRPr>
-            </a:lvl9pPr>
-          </a:lstStyle>
-          <a:p>
-            <a:pPr algn="ctr" eaLnBrk="1" hangingPunct="1"/>
-            <a:r>
-              <a:rPr lang="en-US" sz="2100" b="1" dirty="0">
-                <a:latin typeface="Arial" panose="020B0604020202020204" pitchFamily="34" charset="0"/>
-                <a:cs typeface="Arial" panose="020B0604020202020204" pitchFamily="34" charset="0"/>
-              </a:rPr>
-              <a:t>QR Code for data</a:t>
-            </a:r>
-            <a:endParaRPr lang="en-CA" sz="2100" b="1" dirty="0">
-              <a:latin typeface="Arial" panose="020B0604020202020204" pitchFamily="34" charset="0"/>
-              <a:cs typeface="Arial" panose="020B0604020202020204" pitchFamily="34" charset="0"/>
-            </a:endParaRPr>
-          </a:p>
-        </p:txBody>
-      </p:sp>
-      <p:pic>
-        <p:nvPicPr>
-          <p:cNvPr id="44" name="Picture 43">
-            <a:extLst>
-              <a:ext uri="{FF2B5EF4-FFF2-40B4-BE49-F238E27FC236}">
-                <a16:creationId xmlns:a16="http://schemas.microsoft.com/office/drawing/2014/main" id="{7F4ABE18-5A26-0D43-BE76-448B50832790}"/>
+                <a16:creationId xmlns:a16="http://schemas.microsoft.com/office/drawing/2014/main" id="{893A5802-7BF3-77FF-5812-1A69999519CE}"/>
               </a:ext>
             </a:extLst>
           </p:cNvPr>
@@ -5911,15 +6329,15 @@
           <p:nvPr/>
         </p:nvPicPr>
         <p:blipFill>
-          <a:blip r:embed="rId5"/>
+          <a:blip r:embed="rId8"/>
           <a:stretch>
             <a:fillRect/>
           </a:stretch>
         </p:blipFill>
         <p:spPr>
           <a:xfrm>
-            <a:off x="371423" y="26229219"/>
-            <a:ext cx="2742807" cy="2742807"/>
+            <a:off x="37483272" y="10675491"/>
+            <a:ext cx="5379374" cy="2727043"/>
           </a:xfrm>
           <a:prstGeom prst="rect">
             <a:avLst/>
@@ -5928,269 +6346,51 @@
       </p:pic>
       <p:sp>
         <p:nvSpPr>
-          <p:cNvPr id="45" name="Text Box 10">
+          <p:cNvPr id="37" name="TextBox 36">
             <a:extLst>
               <a:ext uri="{FF2B5EF4-FFF2-40B4-BE49-F238E27FC236}">
-                <a16:creationId xmlns:a16="http://schemas.microsoft.com/office/drawing/2014/main" id="{DA4BEDAA-61D6-D48D-40FE-317BD29DFC17}"/>
+                <a16:creationId xmlns:a16="http://schemas.microsoft.com/office/drawing/2014/main" id="{B4B9C720-9B21-F401-D74B-572E7DDE16A3}"/>
               </a:ext>
             </a:extLst>
           </p:cNvPr>
-          <p:cNvSpPr txBox="1">
-            <a:spLocks noChangeArrowheads="1"/>
-          </p:cNvSpPr>
+          <p:cNvSpPr txBox="1"/>
           <p:nvPr/>
         </p:nvSpPr>
-        <p:spPr bwMode="auto">
+        <p:spPr>
           <a:xfrm>
-            <a:off x="229345" y="29109539"/>
-            <a:ext cx="3100909" cy="724573"/>
+            <a:off x="28706059" y="9844494"/>
+            <a:ext cx="13767838" cy="830997"/>
           </a:xfrm>
           <a:prstGeom prst="rect">
             <a:avLst/>
           </a:prstGeom>
-          <a:noFill/>
-          <a:ln>
-            <a:noFill/>
-          </a:ln>
-          <a:extLst>
-            <a:ext uri="{909E8E84-426E-40dd-AFC4-6F175D3DCCD1}">
-              <a14:hiddenFill xmlns="" xmlns:a14="http://schemas.microsoft.com/office/drawing/2010/main">
-                <a:solidFill>
-                  <a:srgbClr val="FFFFFF"/>
-                </a:solidFill>
-              </a14:hiddenFill>
-            </a:ext>
-            <a:ext uri="{91240B29-F687-4f45-9708-019B960494DF}">
-              <a14:hiddenLine xmlns="" xmlns:a14="http://schemas.microsoft.com/office/drawing/2010/main" w="9525">
-                <a:solidFill>
-                  <a:srgbClr val="000000"/>
-                </a:solidFill>
-                <a:miter lim="800000"/>
-                <a:headEnd/>
-                <a:tailEnd/>
-              </a14:hiddenLine>
-            </a:ext>
-          </a:extLst>
+          <a:solidFill>
+            <a:schemeClr val="accent2"/>
+          </a:solidFill>
         </p:spPr>
         <p:txBody>
-          <a:bodyPr wrap="square" lIns="77486" tIns="38743" rIns="77486" bIns="38743">
+          <a:bodyPr wrap="square" rtlCol="0">
             <a:spAutoFit/>
           </a:bodyPr>
-          <a:lstStyle>
-            <a:lvl1pPr eaLnBrk="0" hangingPunct="0">
-              <a:defRPr sz="2000">
-                <a:solidFill>
-                  <a:schemeClr val="tx1"/>
-                </a:solidFill>
-                <a:latin typeface="Times New Roman" pitchFamily="18" charset="0"/>
-              </a:defRPr>
-            </a:lvl1pPr>
-            <a:lvl2pPr marL="742950" indent="-285750" eaLnBrk="0" hangingPunct="0">
-              <a:defRPr sz="2000">
-                <a:solidFill>
-                  <a:schemeClr val="tx1"/>
-                </a:solidFill>
-                <a:latin typeface="Times New Roman" pitchFamily="18" charset="0"/>
-              </a:defRPr>
-            </a:lvl2pPr>
-            <a:lvl3pPr marL="1143000" indent="-228600" eaLnBrk="0" hangingPunct="0">
-              <a:defRPr sz="2000">
-                <a:solidFill>
-                  <a:schemeClr val="tx1"/>
-                </a:solidFill>
-                <a:latin typeface="Times New Roman" pitchFamily="18" charset="0"/>
-              </a:defRPr>
-            </a:lvl3pPr>
-            <a:lvl4pPr marL="1600200" indent="-228600" eaLnBrk="0" hangingPunct="0">
-              <a:defRPr sz="2000">
-                <a:solidFill>
-                  <a:schemeClr val="tx1"/>
-                </a:solidFill>
-                <a:latin typeface="Times New Roman" pitchFamily="18" charset="0"/>
-              </a:defRPr>
-            </a:lvl4pPr>
-            <a:lvl5pPr marL="2057400" indent="-228600" eaLnBrk="0" hangingPunct="0">
-              <a:defRPr sz="2000">
-                <a:solidFill>
-                  <a:schemeClr val="tx1"/>
-                </a:solidFill>
-                <a:latin typeface="Times New Roman" pitchFamily="18" charset="0"/>
-              </a:defRPr>
-            </a:lvl5pPr>
-            <a:lvl6pPr marL="2514600" indent="-228600" eaLnBrk="0" fontAlgn="base" hangingPunct="0">
-              <a:spcBef>
-                <a:spcPct val="0"/>
-              </a:spcBef>
-              <a:spcAft>
-                <a:spcPct val="0"/>
-              </a:spcAft>
-              <a:defRPr sz="2000">
-                <a:solidFill>
-                  <a:schemeClr val="tx1"/>
-                </a:solidFill>
-                <a:latin typeface="Times New Roman" pitchFamily="18" charset="0"/>
-              </a:defRPr>
-            </a:lvl6pPr>
-            <a:lvl7pPr marL="2971800" indent="-228600" eaLnBrk="0" fontAlgn="base" hangingPunct="0">
-              <a:spcBef>
-                <a:spcPct val="0"/>
-              </a:spcBef>
-              <a:spcAft>
-                <a:spcPct val="0"/>
-              </a:spcAft>
-              <a:defRPr sz="2000">
-                <a:solidFill>
-                  <a:schemeClr val="tx1"/>
-                </a:solidFill>
-                <a:latin typeface="Times New Roman" pitchFamily="18" charset="0"/>
-              </a:defRPr>
-            </a:lvl7pPr>
-            <a:lvl8pPr marL="3429000" indent="-228600" eaLnBrk="0" fontAlgn="base" hangingPunct="0">
-              <a:spcBef>
-                <a:spcPct val="0"/>
-              </a:spcBef>
-              <a:spcAft>
-                <a:spcPct val="0"/>
-              </a:spcAft>
-              <a:defRPr sz="2000">
-                <a:solidFill>
-                  <a:schemeClr val="tx1"/>
-                </a:solidFill>
-                <a:latin typeface="Times New Roman" pitchFamily="18" charset="0"/>
-              </a:defRPr>
-            </a:lvl8pPr>
-            <a:lvl9pPr marL="3886200" indent="-228600" eaLnBrk="0" fontAlgn="base" hangingPunct="0">
-              <a:spcBef>
-                <a:spcPct val="0"/>
-              </a:spcBef>
-              <a:spcAft>
-                <a:spcPct val="0"/>
-              </a:spcAft>
-              <a:defRPr sz="2000">
-                <a:solidFill>
-                  <a:schemeClr val="tx1"/>
-                </a:solidFill>
-                <a:latin typeface="Times New Roman" pitchFamily="18" charset="0"/>
-              </a:defRPr>
-            </a:lvl9pPr>
-          </a:lstStyle>
+          <a:lstStyle/>
           <a:p>
             <a:pPr algn="ctr" eaLnBrk="1" hangingPunct="1"/>
             <a:r>
-              <a:rPr lang="en-US" sz="2100" b="1" dirty="0">
+              <a:rPr lang="en-US" sz="4800" b="1" dirty="0">
                 <a:latin typeface="Arial" panose="020B0604020202020204" pitchFamily="34" charset="0"/>
                 <a:cs typeface="Arial" panose="020B0604020202020204" pitchFamily="34" charset="0"/>
               </a:rPr>
-              <a:t>QR Code for *preprint* module</a:t>
-            </a:r>
-            <a:endParaRPr lang="en-CA" sz="2100" b="1" dirty="0">
-              <a:latin typeface="Arial" panose="020B0604020202020204" pitchFamily="34" charset="0"/>
-              <a:cs typeface="Arial" panose="020B0604020202020204" pitchFamily="34" charset="0"/>
-            </a:endParaRPr>
+              <a:t>Confidence Intervals</a:t>
+            </a:r>
           </a:p>
         </p:txBody>
       </p:sp>
       <p:pic>
         <p:nvPicPr>
-          <p:cNvPr id="47" name="Picture 46" descr="A gold medal with red and white stripes&#10;&#10;Description automatically generated">
+          <p:cNvPr id="42" name="Picture 41">
             <a:extLst>
               <a:ext uri="{FF2B5EF4-FFF2-40B4-BE49-F238E27FC236}">
-                <a16:creationId xmlns:a16="http://schemas.microsoft.com/office/drawing/2014/main" id="{9816EB6B-ED0D-41CA-BD23-D712B16C99C4}"/>
-              </a:ext>
-            </a:extLst>
-          </p:cNvPr>
-          <p:cNvPicPr>
-            <a:picLocks noChangeAspect="1"/>
-          </p:cNvPicPr>
-          <p:nvPr/>
-        </p:nvPicPr>
-        <p:blipFill>
-          <a:blip r:embed="rId6">
-            <a:extLst>
-              <a:ext uri="{28A0092B-C50C-407E-A947-70E740481C1C}">
-                <a14:useLocalDpi xmlns:a14="http://schemas.microsoft.com/office/drawing/2010/main" val="0"/>
-              </a:ext>
-            </a:extLst>
-          </a:blip>
-          <a:stretch>
-            <a:fillRect/>
-          </a:stretch>
-        </p:blipFill>
-        <p:spPr>
-          <a:xfrm>
-            <a:off x="17596156" y="10186119"/>
-            <a:ext cx="6286500" cy="3441700"/>
-          </a:xfrm>
-          <a:prstGeom prst="rect">
-            <a:avLst/>
-          </a:prstGeom>
-        </p:spPr>
-      </p:pic>
-      <p:pic>
-        <p:nvPicPr>
-          <p:cNvPr id="50" name="Picture 49">
-            <a:extLst>
-              <a:ext uri="{FF2B5EF4-FFF2-40B4-BE49-F238E27FC236}">
-                <a16:creationId xmlns:a16="http://schemas.microsoft.com/office/drawing/2014/main" id="{C687A6A8-2C0B-6F57-D6D1-17EAD1E17BEA}"/>
-              </a:ext>
-            </a:extLst>
-          </p:cNvPr>
-          <p:cNvPicPr>
-            <a:picLocks noChangeAspect="1"/>
-          </p:cNvPicPr>
-          <p:nvPr/>
-        </p:nvPicPr>
-        <p:blipFill>
-          <a:blip r:embed="rId7"/>
-          <a:stretch>
-            <a:fillRect/>
-          </a:stretch>
-        </p:blipFill>
-        <p:spPr>
-          <a:xfrm>
-            <a:off x="1174961" y="13877926"/>
-            <a:ext cx="13024661" cy="1635471"/>
-          </a:xfrm>
-          <a:prstGeom prst="rect">
-            <a:avLst/>
-          </a:prstGeom>
-        </p:spPr>
-      </p:pic>
-      <p:pic>
-        <p:nvPicPr>
-          <p:cNvPr id="13" name="Picture 12">
-            <a:extLst>
-              <a:ext uri="{FF2B5EF4-FFF2-40B4-BE49-F238E27FC236}">
-                <a16:creationId xmlns:a16="http://schemas.microsoft.com/office/drawing/2014/main" id="{340022BD-BCCE-DFF3-85A2-517B7605D9E0}"/>
-              </a:ext>
-            </a:extLst>
-          </p:cNvPr>
-          <p:cNvPicPr>
-            <a:picLocks noChangeAspect="1"/>
-          </p:cNvPicPr>
-          <p:nvPr/>
-        </p:nvPicPr>
-        <p:blipFill rotWithShape="1">
-          <a:blip r:embed="rId8"/>
-          <a:srcRect t="14842" b="11032"/>
-          <a:stretch/>
-        </p:blipFill>
-        <p:spPr>
-          <a:xfrm>
-            <a:off x="2375681" y="10906355"/>
-            <a:ext cx="9801166" cy="1353312"/>
-          </a:xfrm>
-          <a:prstGeom prst="rect">
-            <a:avLst/>
-          </a:prstGeom>
-        </p:spPr>
-      </p:pic>
-      <p:pic>
-        <p:nvPicPr>
-          <p:cNvPr id="51" name="Picture 50">
-            <a:extLst>
-              <a:ext uri="{FF2B5EF4-FFF2-40B4-BE49-F238E27FC236}">
-                <a16:creationId xmlns:a16="http://schemas.microsoft.com/office/drawing/2014/main" id="{80AD28F2-3FC1-BAD0-81F0-ED5FB54A760C}"/>
+                <a16:creationId xmlns:a16="http://schemas.microsoft.com/office/drawing/2014/main" id="{ADC2838A-C632-2154-EBE1-C88D86E8F219}"/>
               </a:ext>
             </a:extLst>
           </p:cNvPr>
@@ -6207,8 +6407,8 @@
         </p:blipFill>
         <p:spPr>
           <a:xfrm>
-            <a:off x="28742993" y="14190877"/>
-            <a:ext cx="9946224" cy="2965334"/>
+            <a:off x="40270358" y="12979747"/>
+            <a:ext cx="1663197" cy="1663197"/>
           </a:xfrm>
           <a:prstGeom prst="rect">
             <a:avLst/>
@@ -6217,10 +6417,92 @@
       </p:pic>
       <p:sp>
         <p:nvSpPr>
-          <p:cNvPr id="59" name="Rectangle 58">
+          <p:cNvPr id="57" name="TextBox 56">
             <a:extLst>
               <a:ext uri="{FF2B5EF4-FFF2-40B4-BE49-F238E27FC236}">
-                <a16:creationId xmlns:a16="http://schemas.microsoft.com/office/drawing/2014/main" id="{7ED2883E-0C25-9FDA-9F6D-9BA6F6C98F6A}"/>
+                <a16:creationId xmlns:a16="http://schemas.microsoft.com/office/drawing/2014/main" id="{50C49C76-A1A6-968A-6153-1C03F86EFB00}"/>
+              </a:ext>
+            </a:extLst>
+          </p:cNvPr>
+          <p:cNvSpPr txBox="1"/>
+          <p:nvPr/>
+        </p:nvSpPr>
+        <p:spPr>
+          <a:xfrm>
+            <a:off x="28669784" y="14995971"/>
+            <a:ext cx="13760147" cy="830997"/>
+          </a:xfrm>
+          <a:prstGeom prst="rect">
+            <a:avLst/>
+          </a:prstGeom>
+          <a:solidFill>
+            <a:schemeClr val="accent2"/>
+          </a:solidFill>
+        </p:spPr>
+        <p:txBody>
+          <a:bodyPr wrap="square" rtlCol="0">
+            <a:spAutoFit/>
+          </a:bodyPr>
+          <a:lstStyle/>
+          <a:p>
+            <a:pPr algn="ctr" eaLnBrk="1" hangingPunct="1"/>
+            <a:r>
+              <a:rPr lang="en-US" sz="4800" b="1" dirty="0">
+                <a:latin typeface="Arial" panose="020B0604020202020204" pitchFamily="34" charset="0"/>
+                <a:cs typeface="Arial" panose="020B0604020202020204" pitchFamily="34" charset="0"/>
+              </a:rPr>
+              <a:t>Module Extensions</a:t>
+            </a:r>
+          </a:p>
+        </p:txBody>
+      </p:sp>
+      <p:sp>
+        <p:nvSpPr>
+          <p:cNvPr id="61" name="TextBox 60">
+            <a:extLst>
+              <a:ext uri="{FF2B5EF4-FFF2-40B4-BE49-F238E27FC236}">
+                <a16:creationId xmlns:a16="http://schemas.microsoft.com/office/drawing/2014/main" id="{0C2E86E9-F9DB-4831-F6A7-347FAAF2069F}"/>
+              </a:ext>
+            </a:extLst>
+          </p:cNvPr>
+          <p:cNvSpPr txBox="1"/>
+          <p:nvPr/>
+        </p:nvSpPr>
+        <p:spPr>
+          <a:xfrm>
+            <a:off x="14465455" y="26478342"/>
+            <a:ext cx="13767838" cy="830997"/>
+          </a:xfrm>
+          <a:prstGeom prst="rect">
+            <a:avLst/>
+          </a:prstGeom>
+          <a:solidFill>
+            <a:schemeClr val="accent2"/>
+          </a:solidFill>
+        </p:spPr>
+        <p:txBody>
+          <a:bodyPr wrap="square" rtlCol="0">
+            <a:spAutoFit/>
+          </a:bodyPr>
+          <a:lstStyle/>
+          <a:p>
+            <a:pPr algn="ctr" eaLnBrk="1" hangingPunct="1"/>
+            <a:r>
+              <a:rPr lang="en-US" sz="4800" b="1" dirty="0">
+                <a:latin typeface="Arial" panose="020B0604020202020204" pitchFamily="34" charset="0"/>
+                <a:cs typeface="Arial" panose="020B0604020202020204" pitchFamily="34" charset="0"/>
+              </a:rPr>
+              <a:t>Discussion</a:t>
+            </a:r>
+          </a:p>
+        </p:txBody>
+      </p:sp>
+      <p:sp>
+        <p:nvSpPr>
+          <p:cNvPr id="1033" name="Rectangle 1032">
+            <a:extLst>
+              <a:ext uri="{FF2B5EF4-FFF2-40B4-BE49-F238E27FC236}">
+                <a16:creationId xmlns:a16="http://schemas.microsoft.com/office/drawing/2014/main" id="{CF6229E9-4584-78CC-353C-1EE507E79CE6}"/>
               </a:ext>
             </a:extLst>
           </p:cNvPr>
@@ -6229,8 +6511,8 @@
         </p:nvSpPr>
         <p:spPr>
           <a:xfrm>
-            <a:off x="28558618" y="17964442"/>
-            <a:ext cx="13615376" cy="3701424"/>
+            <a:off x="14670005" y="27492829"/>
+            <a:ext cx="13043388" cy="2480806"/>
           </a:xfrm>
           <a:prstGeom prst="rect">
             <a:avLst/>
@@ -6260,275 +6542,6 @@
           <a:bodyPr rtlCol="0" anchor="ctr"/>
           <a:lstStyle/>
           <a:p>
-            <a:pPr marL="457200" indent="-457200">
-              <a:buFont typeface="Arial" panose="020B0604020202020204" pitchFamily="34" charset="0"/>
-              <a:buChar char="•"/>
-            </a:pPr>
-            <a:r>
-              <a:rPr lang="en-US" sz="3000" b="0" i="0" u="none" strike="noStrike" dirty="0">
-                <a:solidFill>
-                  <a:srgbClr val="000000"/>
-                </a:solidFill>
-                <a:effectLst/>
-                <a:latin typeface="Arial" panose="020B0604020202020204" pitchFamily="34" charset="0"/>
-                <a:cs typeface="Arial" panose="020B0604020202020204" pitchFamily="34" charset="0"/>
-              </a:rPr>
-              <a:t>The scatterplot shows rowers’ goals compared to the split (time per 500 meters) that they achieved on that piece.</a:t>
-            </a:r>
-          </a:p>
-          <a:p>
-            <a:pPr marL="457200" indent="-457200" algn="l" rtl="0">
-              <a:spcBef>
-                <a:spcPts val="0"/>
-              </a:spcBef>
-              <a:spcAft>
-                <a:spcPts val="0"/>
-              </a:spcAft>
-              <a:buFont typeface="Arial" panose="020B0604020202020204" pitchFamily="34" charset="0"/>
-              <a:buChar char="•"/>
-            </a:pPr>
-            <a:r>
-              <a:rPr lang="en-US" sz="3000" b="0" i="0" u="none" strike="noStrike" dirty="0">
-                <a:solidFill>
-                  <a:srgbClr val="000000"/>
-                </a:solidFill>
-                <a:effectLst/>
-                <a:latin typeface="Arial" panose="020B0604020202020204" pitchFamily="34" charset="0"/>
-                <a:cs typeface="Arial" panose="020B0604020202020204" pitchFamily="34" charset="0"/>
-              </a:rPr>
-              <a:t>The confidence interval and visualization show that many athletes are meeting their goals during test pieces indicating that they should reassess how ambitious their aim is.</a:t>
-            </a:r>
-          </a:p>
-        </p:txBody>
-      </p:sp>
-      <p:pic>
-        <p:nvPicPr>
-          <p:cNvPr id="41" name="Picture 40">
-            <a:extLst>
-              <a:ext uri="{FF2B5EF4-FFF2-40B4-BE49-F238E27FC236}">
-                <a16:creationId xmlns:a16="http://schemas.microsoft.com/office/drawing/2014/main" id="{893A5802-7BF3-77FF-5812-1A69999519CE}"/>
-              </a:ext>
-            </a:extLst>
-          </p:cNvPr>
-          <p:cNvPicPr>
-            <a:picLocks noChangeAspect="1"/>
-          </p:cNvPicPr>
-          <p:nvPr/>
-        </p:nvPicPr>
-        <p:blipFill>
-          <a:blip r:embed="rId10"/>
-          <a:stretch>
-            <a:fillRect/>
-          </a:stretch>
-        </p:blipFill>
-        <p:spPr>
-          <a:xfrm>
-            <a:off x="37483272" y="11188808"/>
-            <a:ext cx="5379374" cy="2727043"/>
-          </a:xfrm>
-          <a:prstGeom prst="rect">
-            <a:avLst/>
-          </a:prstGeom>
-        </p:spPr>
-      </p:pic>
-      <p:sp>
-        <p:nvSpPr>
-          <p:cNvPr id="37" name="TextBox 36">
-            <a:extLst>
-              <a:ext uri="{FF2B5EF4-FFF2-40B4-BE49-F238E27FC236}">
-                <a16:creationId xmlns:a16="http://schemas.microsoft.com/office/drawing/2014/main" id="{B4B9C720-9B21-F401-D74B-572E7DDE16A3}"/>
-              </a:ext>
-            </a:extLst>
-          </p:cNvPr>
-          <p:cNvSpPr txBox="1"/>
-          <p:nvPr/>
-        </p:nvSpPr>
-        <p:spPr>
-          <a:xfrm>
-            <a:off x="28706059" y="10498402"/>
-            <a:ext cx="13767838" cy="923330"/>
-          </a:xfrm>
-          <a:prstGeom prst="rect">
-            <a:avLst/>
-          </a:prstGeom>
-          <a:solidFill>
-            <a:schemeClr val="accent2"/>
-          </a:solidFill>
-        </p:spPr>
-        <p:txBody>
-          <a:bodyPr wrap="square" rtlCol="0">
-            <a:spAutoFit/>
-          </a:bodyPr>
-          <a:lstStyle/>
-          <a:p>
-            <a:pPr algn="ctr" eaLnBrk="1" hangingPunct="1"/>
-            <a:r>
-              <a:rPr lang="en-US" sz="5400" b="1" dirty="0">
-                <a:latin typeface="Arial" panose="020B0604020202020204" pitchFamily="34" charset="0"/>
-                <a:cs typeface="Arial" panose="020B0604020202020204" pitchFamily="34" charset="0"/>
-              </a:rPr>
-              <a:t>Confidence Intervals</a:t>
-            </a:r>
-          </a:p>
-        </p:txBody>
-      </p:sp>
-      <p:pic>
-        <p:nvPicPr>
-          <p:cNvPr id="42" name="Picture 41">
-            <a:extLst>
-              <a:ext uri="{FF2B5EF4-FFF2-40B4-BE49-F238E27FC236}">
-                <a16:creationId xmlns:a16="http://schemas.microsoft.com/office/drawing/2014/main" id="{ADC2838A-C632-2154-EBE1-C88D86E8F219}"/>
-              </a:ext>
-            </a:extLst>
-          </p:cNvPr>
-          <p:cNvPicPr>
-            <a:picLocks noChangeAspect="1"/>
-          </p:cNvPicPr>
-          <p:nvPr/>
-        </p:nvPicPr>
-        <p:blipFill>
-          <a:blip r:embed="rId11"/>
-          <a:stretch>
-            <a:fillRect/>
-          </a:stretch>
-        </p:blipFill>
-        <p:spPr>
-          <a:xfrm>
-            <a:off x="38866128" y="13656736"/>
-            <a:ext cx="3067427" cy="3067427"/>
-          </a:xfrm>
-          <a:prstGeom prst="rect">
-            <a:avLst/>
-          </a:prstGeom>
-        </p:spPr>
-      </p:pic>
-      <p:sp>
-        <p:nvSpPr>
-          <p:cNvPr id="57" name="TextBox 56">
-            <a:extLst>
-              <a:ext uri="{FF2B5EF4-FFF2-40B4-BE49-F238E27FC236}">
-                <a16:creationId xmlns:a16="http://schemas.microsoft.com/office/drawing/2014/main" id="{50C49C76-A1A6-968A-6153-1C03F86EFB00}"/>
-              </a:ext>
-            </a:extLst>
-          </p:cNvPr>
-          <p:cNvSpPr txBox="1"/>
-          <p:nvPr/>
-        </p:nvSpPr>
-        <p:spPr>
-          <a:xfrm>
-            <a:off x="28670690" y="17601033"/>
-            <a:ext cx="13760147" cy="923330"/>
-          </a:xfrm>
-          <a:prstGeom prst="rect">
-            <a:avLst/>
-          </a:prstGeom>
-          <a:solidFill>
-            <a:schemeClr val="accent2"/>
-          </a:solidFill>
-        </p:spPr>
-        <p:txBody>
-          <a:bodyPr wrap="square" rtlCol="0">
-            <a:spAutoFit/>
-          </a:bodyPr>
-          <a:lstStyle/>
-          <a:p>
-            <a:pPr algn="ctr" eaLnBrk="1" hangingPunct="1"/>
-            <a:r>
-              <a:rPr lang="en-US" sz="5400" b="1" dirty="0">
-                <a:latin typeface="Arial" panose="020B0604020202020204" pitchFamily="34" charset="0"/>
-                <a:cs typeface="Arial" panose="020B0604020202020204" pitchFamily="34" charset="0"/>
-              </a:rPr>
-              <a:t>Visualizing Results</a:t>
-            </a:r>
-          </a:p>
-        </p:txBody>
-      </p:sp>
-      <p:sp>
-        <p:nvSpPr>
-          <p:cNvPr id="61" name="TextBox 60">
-            <a:extLst>
-              <a:ext uri="{FF2B5EF4-FFF2-40B4-BE49-F238E27FC236}">
-                <a16:creationId xmlns:a16="http://schemas.microsoft.com/office/drawing/2014/main" id="{0C2E86E9-F9DB-4831-F6A7-347FAAF2069F}"/>
-              </a:ext>
-            </a:extLst>
-          </p:cNvPr>
-          <p:cNvSpPr txBox="1"/>
-          <p:nvPr/>
-        </p:nvSpPr>
-        <p:spPr>
-          <a:xfrm>
-            <a:off x="14549192" y="21288539"/>
-            <a:ext cx="13767838" cy="923330"/>
-          </a:xfrm>
-          <a:prstGeom prst="rect">
-            <a:avLst/>
-          </a:prstGeom>
-          <a:solidFill>
-            <a:schemeClr val="accent2"/>
-          </a:solidFill>
-        </p:spPr>
-        <p:txBody>
-          <a:bodyPr wrap="square" rtlCol="0">
-            <a:spAutoFit/>
-          </a:bodyPr>
-          <a:lstStyle/>
-          <a:p>
-            <a:pPr algn="ctr" eaLnBrk="1" hangingPunct="1"/>
-            <a:r>
-              <a:rPr lang="en-US" sz="5400" b="1" dirty="0">
-                <a:latin typeface="Arial" panose="020B0604020202020204" pitchFamily="34" charset="0"/>
-                <a:cs typeface="Arial" panose="020B0604020202020204" pitchFamily="34" charset="0"/>
-              </a:rPr>
-              <a:t>Discussion</a:t>
-            </a:r>
-          </a:p>
-        </p:txBody>
-      </p:sp>
-      <p:sp>
-        <p:nvSpPr>
-          <p:cNvPr id="1033" name="Rectangle 1032">
-            <a:extLst>
-              <a:ext uri="{FF2B5EF4-FFF2-40B4-BE49-F238E27FC236}">
-                <a16:creationId xmlns:a16="http://schemas.microsoft.com/office/drawing/2014/main" id="{CF6229E9-4584-78CC-353C-1EE507E79CE6}"/>
-              </a:ext>
-            </a:extLst>
-          </p:cNvPr>
-          <p:cNvSpPr/>
-          <p:nvPr/>
-        </p:nvSpPr>
-        <p:spPr>
-          <a:xfrm>
-            <a:off x="14815266" y="22236155"/>
-            <a:ext cx="12774723" cy="2480806"/>
-          </a:xfrm>
-          <a:prstGeom prst="rect">
-            <a:avLst/>
-          </a:prstGeom>
-          <a:solidFill>
-            <a:schemeClr val="bg1"/>
-          </a:solidFill>
-          <a:ln>
-            <a:noFill/>
-          </a:ln>
-        </p:spPr>
-        <p:style>
-          <a:lnRef idx="2">
-            <a:schemeClr val="dk1"/>
-          </a:lnRef>
-          <a:fillRef idx="1">
-            <a:schemeClr val="lt1"/>
-          </a:fillRef>
-          <a:effectRef idx="0">
-            <a:schemeClr val="dk1"/>
-          </a:effectRef>
-          <a:fontRef idx="minor">
-            <a:schemeClr val="dk1"/>
-          </a:fontRef>
-        </p:style>
-        <p:txBody>
-          <a:bodyPr rtlCol="0" anchor="ctr"/>
-          <a:lstStyle/>
-          <a:p>
             <a:pPr marL="457200" indent="-457200" algn="l" rtl="0">
               <a:spcBef>
                 <a:spcPts val="0"/>
@@ -6593,8 +6606,8 @@
             </p:nvSpPr>
             <p:spPr>
               <a:xfrm>
-                <a:off x="28677070" y="11785141"/>
-                <a:ext cx="9041868" cy="2130710"/>
+                <a:off x="28677070" y="10936252"/>
+                <a:ext cx="9041868" cy="3627671"/>
               </a:xfrm>
               <a:prstGeom prst="rect">
                 <a:avLst/>
@@ -6643,7 +6656,7 @@
                     <a:latin typeface="Arial" panose="020B0604020202020204" pitchFamily="34" charset="0"/>
                     <a:cs typeface="Arial" panose="020B0604020202020204" pitchFamily="34" charset="0"/>
                   </a:rPr>
-                  <a:t>Estimating the proportion of athletes that meet or exceed their goal for a test piece</a:t>
+                  <a:t>Estimating the proportion of athletes that meet or exceed their goal for a test piece.</a:t>
                 </a:r>
               </a:p>
               <a:p>
@@ -6683,11 +6696,54 @@
                   <a:rPr lang="en-US" sz="3200" dirty="0">
                     <a:effectLst/>
                   </a:rPr>
-                  <a:t>) is the true proportion of rowers that meet or exceed their goal</a:t>
+                  <a:t>) is the true proportion of rowers that meet or exceed their goal.</a:t>
+                </a:r>
+              </a:p>
+              <a:p>
+                <a:pPr marL="457200" indent="-457200">
+                  <a:buFont typeface="Arial" panose="020B0604020202020204" pitchFamily="34" charset="0"/>
+                  <a:buChar char="•"/>
+                </a:pPr>
+                <a:r>
+                  <a:rPr lang="en-US" sz="3200" b="0" i="0" u="none" strike="noStrike" dirty="0">
+                    <a:solidFill>
+                      <a:schemeClr val="tx1"/>
+                    </a:solidFill>
+                    <a:latin typeface="Arial" panose="020B0604020202020204" pitchFamily="34" charset="0"/>
+                    <a:cs typeface="Arial" panose="020B0604020202020204" pitchFamily="34" charset="0"/>
+                  </a:rPr>
+                  <a:t>Students work through a single proportion test and get a result of: </a:t>
+                </a:r>
+              </a:p>
+              <a:p>
+                <a:pPr marL="457200" indent="-457200">
+                  <a:buFont typeface="Arial" panose="020B0604020202020204" pitchFamily="34" charset="0"/>
+                  <a:buChar char="•"/>
+                </a:pPr>
+                <a:r>
+                  <a:rPr lang="en-US" sz="3200" dirty="0">
+                    <a:solidFill>
+                      <a:schemeClr val="tx1"/>
+                    </a:solidFill>
+                    <a:effectLst/>
+                    <a:latin typeface="Arial" panose="020B0604020202020204" pitchFamily="34" charset="0"/>
+                    <a:cs typeface="Arial" panose="020B0604020202020204" pitchFamily="34" charset="0"/>
+                  </a:rPr>
+                  <a:t>Confidence Interval = (0.59</a:t>
+                </a:r>
+                <a:r>
+                  <a:rPr lang="en-US" sz="3200" dirty="0">
+                    <a:solidFill>
+                      <a:schemeClr val="tx1"/>
+                    </a:solidFill>
+                    <a:latin typeface="Arial" panose="020B0604020202020204" pitchFamily="34" charset="0"/>
+                    <a:cs typeface="Arial" panose="020B0604020202020204" pitchFamily="34" charset="0"/>
+                  </a:rPr>
+                  <a:t>15, 0.6005)</a:t>
                 </a:r>
                 <a:endParaRPr lang="en-US" sz="3000" b="0" i="0" u="none" strike="noStrike" dirty="0">
                   <a:solidFill>
-                    <a:srgbClr val="000000"/>
+                    <a:schemeClr val="tx1"/>
                   </a:solidFill>
                   <a:effectLst/>
                   <a:latin typeface="Arial" panose="020B0604020202020204" pitchFamily="34" charset="0"/>
@@ -6714,16 +6770,16 @@
             </p:nvSpPr>
             <p:spPr>
               <a:xfrm>
-                <a:off x="28677070" y="11785141"/>
-                <a:ext cx="9041868" cy="2130710"/>
+                <a:off x="28677070" y="10936252"/>
+                <a:ext cx="9041868" cy="3627671"/>
               </a:xfrm>
               <a:prstGeom prst="rect">
                 <a:avLst/>
               </a:prstGeom>
               <a:blipFill>
-                <a:blip r:embed="rId12"/>
+                <a:blip r:embed="rId10"/>
                 <a:stretch>
-                  <a:fillRect l="-1403" t="-10651" r="-842" b="-17160"/>
+                  <a:fillRect l="-1543" t="-6294" r="-842" b="-9790"/>
                 </a:stretch>
               </a:blipFill>
               <a:ln>
@@ -6745,6 +6801,807 @@
           </p:sp>
         </mc:Fallback>
       </mc:AlternateContent>
+      <p:pic>
+        <p:nvPicPr>
+          <p:cNvPr id="1034" name="Picture 1033">
+            <a:extLst>
+              <a:ext uri="{FF2B5EF4-FFF2-40B4-BE49-F238E27FC236}">
+                <a16:creationId xmlns:a16="http://schemas.microsoft.com/office/drawing/2014/main" id="{254E6D2F-6064-A2CA-A8BB-9306CD1750B7}"/>
+              </a:ext>
+            </a:extLst>
+          </p:cNvPr>
+          <p:cNvPicPr>
+            <a:picLocks noChangeAspect="1"/>
+          </p:cNvPicPr>
+          <p:nvPr/>
+        </p:nvPicPr>
+        <p:blipFill rotWithShape="1">
+          <a:blip r:embed="rId3"/>
+          <a:srcRect t="39263" b="39772"/>
+          <a:stretch/>
+        </p:blipFill>
+        <p:spPr>
+          <a:xfrm>
+            <a:off x="34797750" y="1508797"/>
+            <a:ext cx="7511177" cy="2037902"/>
+          </a:xfrm>
+          <a:prstGeom prst="rect">
+            <a:avLst/>
+          </a:prstGeom>
+        </p:spPr>
+      </p:pic>
+      <p:pic>
+        <p:nvPicPr>
+          <p:cNvPr id="1039" name="Picture 1038" descr="A graph with red dots&#10;&#10;Description automatically generated">
+            <a:extLst>
+              <a:ext uri="{FF2B5EF4-FFF2-40B4-BE49-F238E27FC236}">
+                <a16:creationId xmlns:a16="http://schemas.microsoft.com/office/drawing/2014/main" id="{F56BD141-ECDF-F44B-AD13-F245E4D4E2FC}"/>
+              </a:ext>
+            </a:extLst>
+          </p:cNvPr>
+          <p:cNvPicPr>
+            <a:picLocks noChangeAspect="1"/>
+          </p:cNvPicPr>
+          <p:nvPr/>
+        </p:nvPicPr>
+        <p:blipFill>
+          <a:blip r:embed="rId11">
+            <a:extLst>
+              <a:ext uri="{28A0092B-C50C-407E-A947-70E740481C1C}">
+                <a14:useLocalDpi xmlns:a14="http://schemas.microsoft.com/office/drawing/2010/main" val="0"/>
+              </a:ext>
+            </a:extLst>
+          </a:blip>
+          <a:stretch>
+            <a:fillRect/>
+          </a:stretch>
+        </p:blipFill>
+        <p:spPr>
+          <a:xfrm>
+            <a:off x="30828934" y="18812395"/>
+            <a:ext cx="9074744" cy="6420471"/>
+          </a:xfrm>
+          <a:prstGeom prst="rect">
+            <a:avLst/>
+          </a:prstGeom>
+        </p:spPr>
+      </p:pic>
+      <p:pic>
+        <p:nvPicPr>
+          <p:cNvPr id="1043" name="Picture 1042" descr="A graph of a graph of a graph&#10;&#10;Description automatically generated with medium confidence">
+            <a:extLst>
+              <a:ext uri="{FF2B5EF4-FFF2-40B4-BE49-F238E27FC236}">
+                <a16:creationId xmlns:a16="http://schemas.microsoft.com/office/drawing/2014/main" id="{B97298BB-4DAA-1644-BEE2-984977B5F059}"/>
+              </a:ext>
+            </a:extLst>
+          </p:cNvPr>
+          <p:cNvPicPr>
+            <a:picLocks noChangeAspect="1"/>
+          </p:cNvPicPr>
+          <p:nvPr/>
+        </p:nvPicPr>
+        <p:blipFill>
+          <a:blip r:embed="rId12">
+            <a:extLst>
+              <a:ext uri="{28A0092B-C50C-407E-A947-70E740481C1C}">
+                <a14:useLocalDpi xmlns:a14="http://schemas.microsoft.com/office/drawing/2010/main" val="0"/>
+              </a:ext>
+            </a:extLst>
+          </a:blip>
+          <a:stretch>
+            <a:fillRect/>
+          </a:stretch>
+        </p:blipFill>
+        <p:spPr>
+          <a:xfrm>
+            <a:off x="144801" y="22268779"/>
+            <a:ext cx="6959470" cy="5061433"/>
+          </a:xfrm>
+          <a:prstGeom prst="rect">
+            <a:avLst/>
+          </a:prstGeom>
+        </p:spPr>
+      </p:pic>
+      <p:sp>
+        <p:nvSpPr>
+          <p:cNvPr id="1044" name="Text Box 10">
+            <a:extLst>
+              <a:ext uri="{FF2B5EF4-FFF2-40B4-BE49-F238E27FC236}">
+                <a16:creationId xmlns:a16="http://schemas.microsoft.com/office/drawing/2014/main" id="{BD7FE81A-168D-6C3F-6CDD-508CB71FAD85}"/>
+              </a:ext>
+            </a:extLst>
+          </p:cNvPr>
+          <p:cNvSpPr txBox="1">
+            <a:spLocks noChangeArrowheads="1"/>
+          </p:cNvSpPr>
+          <p:nvPr/>
+        </p:nvSpPr>
+        <p:spPr bwMode="auto">
+          <a:xfrm>
+            <a:off x="249130" y="27405807"/>
+            <a:ext cx="6762291" cy="401408"/>
+          </a:xfrm>
+          <a:prstGeom prst="rect">
+            <a:avLst/>
+          </a:prstGeom>
+          <a:noFill/>
+          <a:ln>
+            <a:noFill/>
+          </a:ln>
+          <a:extLst>
+            <a:ext uri="{909E8E84-426E-40dd-AFC4-6F175D3DCCD1}">
+              <a14:hiddenFill xmlns="" xmlns:a14="http://schemas.microsoft.com/office/drawing/2010/main">
+                <a:solidFill>
+                  <a:srgbClr val="FFFFFF"/>
+                </a:solidFill>
+              </a14:hiddenFill>
+            </a:ext>
+            <a:ext uri="{91240B29-F687-4f45-9708-019B960494DF}">
+              <a14:hiddenLine xmlns="" xmlns:a14="http://schemas.microsoft.com/office/drawing/2010/main" w="9525">
+                <a:solidFill>
+                  <a:srgbClr val="000000"/>
+                </a:solidFill>
+                <a:miter lim="800000"/>
+                <a:headEnd/>
+                <a:tailEnd/>
+              </a14:hiddenLine>
+            </a:ext>
+          </a:extLst>
+        </p:spPr>
+        <p:txBody>
+          <a:bodyPr wrap="square" lIns="77486" tIns="38743" rIns="77486" bIns="38743">
+            <a:spAutoFit/>
+          </a:bodyPr>
+          <a:lstStyle>
+            <a:lvl1pPr eaLnBrk="0" hangingPunct="0">
+              <a:defRPr sz="2000">
+                <a:solidFill>
+                  <a:schemeClr val="tx1"/>
+                </a:solidFill>
+                <a:latin typeface="Times New Roman" pitchFamily="18" charset="0"/>
+              </a:defRPr>
+            </a:lvl1pPr>
+            <a:lvl2pPr marL="742950" indent="-285750" eaLnBrk="0" hangingPunct="0">
+              <a:defRPr sz="2000">
+                <a:solidFill>
+                  <a:schemeClr val="tx1"/>
+                </a:solidFill>
+                <a:latin typeface="Times New Roman" pitchFamily="18" charset="0"/>
+              </a:defRPr>
+            </a:lvl2pPr>
+            <a:lvl3pPr marL="1143000" indent="-228600" eaLnBrk="0" hangingPunct="0">
+              <a:defRPr sz="2000">
+                <a:solidFill>
+                  <a:schemeClr val="tx1"/>
+                </a:solidFill>
+                <a:latin typeface="Times New Roman" pitchFamily="18" charset="0"/>
+              </a:defRPr>
+            </a:lvl3pPr>
+            <a:lvl4pPr marL="1600200" indent="-228600" eaLnBrk="0" hangingPunct="0">
+              <a:defRPr sz="2000">
+                <a:solidFill>
+                  <a:schemeClr val="tx1"/>
+                </a:solidFill>
+                <a:latin typeface="Times New Roman" pitchFamily="18" charset="0"/>
+              </a:defRPr>
+            </a:lvl4pPr>
+            <a:lvl5pPr marL="2057400" indent="-228600" eaLnBrk="0" hangingPunct="0">
+              <a:defRPr sz="2000">
+                <a:solidFill>
+                  <a:schemeClr val="tx1"/>
+                </a:solidFill>
+                <a:latin typeface="Times New Roman" pitchFamily="18" charset="0"/>
+              </a:defRPr>
+            </a:lvl5pPr>
+            <a:lvl6pPr marL="2514600" indent="-228600" eaLnBrk="0" fontAlgn="base" hangingPunct="0">
+              <a:spcBef>
+                <a:spcPct val="0"/>
+              </a:spcBef>
+              <a:spcAft>
+                <a:spcPct val="0"/>
+              </a:spcAft>
+              <a:defRPr sz="2000">
+                <a:solidFill>
+                  <a:schemeClr val="tx1"/>
+                </a:solidFill>
+                <a:latin typeface="Times New Roman" pitchFamily="18" charset="0"/>
+              </a:defRPr>
+            </a:lvl6pPr>
+            <a:lvl7pPr marL="2971800" indent="-228600" eaLnBrk="0" fontAlgn="base" hangingPunct="0">
+              <a:spcBef>
+                <a:spcPct val="0"/>
+              </a:spcBef>
+              <a:spcAft>
+                <a:spcPct val="0"/>
+              </a:spcAft>
+              <a:defRPr sz="2000">
+                <a:solidFill>
+                  <a:schemeClr val="tx1"/>
+                </a:solidFill>
+                <a:latin typeface="Times New Roman" pitchFamily="18" charset="0"/>
+              </a:defRPr>
+            </a:lvl7pPr>
+            <a:lvl8pPr marL="3429000" indent="-228600" eaLnBrk="0" fontAlgn="base" hangingPunct="0">
+              <a:spcBef>
+                <a:spcPct val="0"/>
+              </a:spcBef>
+              <a:spcAft>
+                <a:spcPct val="0"/>
+              </a:spcAft>
+              <a:defRPr sz="2000">
+                <a:solidFill>
+                  <a:schemeClr val="tx1"/>
+                </a:solidFill>
+                <a:latin typeface="Times New Roman" pitchFamily="18" charset="0"/>
+              </a:defRPr>
+            </a:lvl8pPr>
+            <a:lvl9pPr marL="3886200" indent="-228600" eaLnBrk="0" fontAlgn="base" hangingPunct="0">
+              <a:spcBef>
+                <a:spcPct val="0"/>
+              </a:spcBef>
+              <a:spcAft>
+                <a:spcPct val="0"/>
+              </a:spcAft>
+              <a:defRPr sz="2000">
+                <a:solidFill>
+                  <a:schemeClr val="tx1"/>
+                </a:solidFill>
+                <a:latin typeface="Times New Roman" pitchFamily="18" charset="0"/>
+              </a:defRPr>
+            </a:lvl9pPr>
+          </a:lstStyle>
+          <a:p>
+            <a:pPr algn="ctr" eaLnBrk="1" hangingPunct="1"/>
+            <a:r>
+              <a:rPr lang="en-US" sz="2100" b="1" dirty="0">
+                <a:latin typeface="Arial" panose="020B0604020202020204" pitchFamily="34" charset="0"/>
+                <a:cs typeface="Arial" panose="020B0604020202020204" pitchFamily="34" charset="0"/>
+              </a:rPr>
+              <a:t>Figure 1. Boxplot of Benching Weight by Age Class</a:t>
+            </a:r>
+            <a:endParaRPr lang="en-CA" sz="2100" b="1" dirty="0">
+              <a:latin typeface="Arial" panose="020B0604020202020204" pitchFamily="34" charset="0"/>
+              <a:cs typeface="Arial" panose="020B0604020202020204" pitchFamily="34" charset="0"/>
+            </a:endParaRPr>
+          </a:p>
+        </p:txBody>
+      </p:sp>
+      <p:sp>
+        <p:nvSpPr>
+          <p:cNvPr id="1046" name="TextBox 1045">
+            <a:extLst>
+              <a:ext uri="{FF2B5EF4-FFF2-40B4-BE49-F238E27FC236}">
+                <a16:creationId xmlns:a16="http://schemas.microsoft.com/office/drawing/2014/main" id="{6F4E8EEE-AEF5-6758-A24E-9EFE932813B2}"/>
+              </a:ext>
+            </a:extLst>
+          </p:cNvPr>
+          <p:cNvSpPr txBox="1"/>
+          <p:nvPr/>
+        </p:nvSpPr>
+        <p:spPr>
+          <a:xfrm>
+            <a:off x="899193" y="12418779"/>
+            <a:ext cx="13092777" cy="954107"/>
+          </a:xfrm>
+          <a:prstGeom prst="rect">
+            <a:avLst/>
+          </a:prstGeom>
+          <a:noFill/>
+        </p:spPr>
+        <p:txBody>
+          <a:bodyPr wrap="square" rtlCol="0">
+            <a:spAutoFit/>
+          </a:bodyPr>
+          <a:lstStyle/>
+          <a:p>
+            <a:r>
+              <a:rPr lang="en-US" sz="2800" dirty="0">
+                <a:latin typeface="Arial" panose="020B0604020202020204" pitchFamily="34" charset="0"/>
+                <a:cs typeface="Arial" panose="020B0604020202020204" pitchFamily="34" charset="0"/>
+              </a:rPr>
+              <a:t>H</a:t>
+            </a:r>
+            <a:r>
+              <a:rPr lang="en-US" sz="2800" baseline="-25000" dirty="0">
+                <a:latin typeface="Arial" panose="020B0604020202020204" pitchFamily="34" charset="0"/>
+                <a:cs typeface="Arial" panose="020B0604020202020204" pitchFamily="34" charset="0"/>
+              </a:rPr>
+              <a:t>0</a:t>
+            </a:r>
+            <a:r>
+              <a:rPr lang="en-US" sz="2800" dirty="0">
+                <a:latin typeface="Arial" panose="020B0604020202020204" pitchFamily="34" charset="0"/>
+                <a:cs typeface="Arial" panose="020B0604020202020204" pitchFamily="34" charset="0"/>
+              </a:rPr>
+              <a:t>= there is no difference in the median powerlifting weight between age classes.</a:t>
+            </a:r>
+          </a:p>
+          <a:p>
+            <a:r>
+              <a:rPr lang="en-US" sz="2800" dirty="0">
+                <a:latin typeface="Arial" panose="020B0604020202020204" pitchFamily="34" charset="0"/>
+                <a:cs typeface="Arial" panose="020B0604020202020204" pitchFamily="34" charset="0"/>
+              </a:rPr>
+              <a:t>H</a:t>
+            </a:r>
+            <a:r>
+              <a:rPr lang="en-US" sz="2800" baseline="-25000" dirty="0">
+                <a:latin typeface="Arial" panose="020B0604020202020204" pitchFamily="34" charset="0"/>
+                <a:cs typeface="Arial" panose="020B0604020202020204" pitchFamily="34" charset="0"/>
+              </a:rPr>
+              <a:t>a </a:t>
+            </a:r>
+            <a:r>
+              <a:rPr lang="en-US" sz="2800" dirty="0">
+                <a:latin typeface="Arial" panose="020B0604020202020204" pitchFamily="34" charset="0"/>
+                <a:cs typeface="Arial" panose="020B0604020202020204" pitchFamily="34" charset="0"/>
+              </a:rPr>
+              <a:t>=at least one group differs from another.</a:t>
+            </a:r>
+          </a:p>
+        </p:txBody>
+      </p:sp>
+      <mc:AlternateContent xmlns:mc="http://schemas.openxmlformats.org/markup-compatibility/2006">
+        <mc:Choice xmlns:a14="http://schemas.microsoft.com/office/drawing/2010/main" Requires="a14">
+          <p:sp>
+            <p:nvSpPr>
+              <p:cNvPr id="1047" name="TextBox 1046">
+                <a:extLst>
+                  <a:ext uri="{FF2B5EF4-FFF2-40B4-BE49-F238E27FC236}">
+                    <a16:creationId xmlns:a16="http://schemas.microsoft.com/office/drawing/2014/main" id="{916C0D3D-F044-D54B-CD11-61C3CD3FD552}"/>
+                  </a:ext>
+                </a:extLst>
+              </p:cNvPr>
+              <p:cNvSpPr txBox="1"/>
+              <p:nvPr/>
+            </p:nvSpPr>
+            <p:spPr>
+              <a:xfrm>
+                <a:off x="4674181" y="13890310"/>
+                <a:ext cx="6929120" cy="1574085"/>
+              </a:xfrm>
+              <a:prstGeom prst="rect">
+                <a:avLst/>
+              </a:prstGeom>
+              <a:noFill/>
+            </p:spPr>
+            <p:txBody>
+              <a:bodyPr wrap="square" rtlCol="0">
+                <a:spAutoFit/>
+              </a:bodyPr>
+              <a:lstStyle/>
+              <a:p>
+                <a14:m>
+                  <m:oMathPara xmlns:m="http://schemas.openxmlformats.org/officeDocument/2006/math">
+                    <m:oMathParaPr>
+                      <m:jc m:val="centerGroup"/>
+                    </m:oMathParaPr>
+                    <m:oMath xmlns:m="http://schemas.openxmlformats.org/officeDocument/2006/math">
+                      <m:r>
+                        <a:rPr lang="en-US" sz="3400" b="0" i="1" u="none" strike="noStrike" smtClean="0">
+                          <a:solidFill>
+                            <a:srgbClr val="000000"/>
+                          </a:solidFill>
+                          <a:effectLst/>
+                          <a:latin typeface="Cambria Math" panose="02040503050406030204" pitchFamily="18" charset="0"/>
+                          <a:ea typeface="Lato" panose="020F0502020204030203" pitchFamily="34" charset="0"/>
+                          <a:cs typeface="Arial" panose="020B0604020202020204" pitchFamily="34" charset="0"/>
+                        </a:rPr>
+                        <m:t>𝐻</m:t>
+                      </m:r>
+                      <m:r>
+                        <a:rPr lang="en-US" sz="3400" b="0" i="1" u="none" strike="noStrike" smtClean="0">
+                          <a:solidFill>
+                            <a:srgbClr val="000000"/>
+                          </a:solidFill>
+                          <a:effectLst/>
+                          <a:latin typeface="Cambria Math" panose="02040503050406030204" pitchFamily="18" charset="0"/>
+                          <a:ea typeface="Lato" panose="020F0502020204030203" pitchFamily="34" charset="0"/>
+                          <a:cs typeface="Arial" panose="020B0604020202020204" pitchFamily="34" charset="0"/>
+                        </a:rPr>
+                        <m:t>= </m:t>
+                      </m:r>
+                      <m:f>
+                        <m:fPr>
+                          <m:ctrlPr>
+                            <a:rPr lang="en-US" sz="3400" b="0" i="1" u="none" strike="noStrike" smtClean="0">
+                              <a:solidFill>
+                                <a:srgbClr val="000000"/>
+                              </a:solidFill>
+                              <a:effectLst/>
+                              <a:latin typeface="Cambria Math" panose="02040503050406030204" pitchFamily="18" charset="0"/>
+                              <a:ea typeface="Lato" panose="020F0502020204030203" pitchFamily="34" charset="0"/>
+                              <a:cs typeface="Arial" panose="020B0604020202020204" pitchFamily="34" charset="0"/>
+                            </a:rPr>
+                          </m:ctrlPr>
+                        </m:fPr>
+                        <m:num>
+                          <m:r>
+                            <a:rPr lang="en-US" sz="3400" b="0" i="1" u="none" strike="noStrike" smtClean="0">
+                              <a:solidFill>
+                                <a:srgbClr val="000000"/>
+                              </a:solidFill>
+                              <a:effectLst/>
+                              <a:latin typeface="Cambria Math" panose="02040503050406030204" pitchFamily="18" charset="0"/>
+                              <a:ea typeface="Lato" panose="020F0502020204030203" pitchFamily="34" charset="0"/>
+                              <a:cs typeface="Arial" panose="020B0604020202020204" pitchFamily="34" charset="0"/>
+                            </a:rPr>
+                            <m:t>12</m:t>
+                          </m:r>
+                        </m:num>
+                        <m:den>
+                          <m:r>
+                            <a:rPr lang="en-US" sz="3400" b="0" i="1" u="none" strike="noStrike" smtClean="0">
+                              <a:solidFill>
+                                <a:srgbClr val="000000"/>
+                              </a:solidFill>
+                              <a:effectLst/>
+                              <a:latin typeface="Cambria Math" panose="02040503050406030204" pitchFamily="18" charset="0"/>
+                              <a:ea typeface="Lato" panose="020F0502020204030203" pitchFamily="34" charset="0"/>
+                              <a:cs typeface="Arial" panose="020B0604020202020204" pitchFamily="34" charset="0"/>
+                            </a:rPr>
+                            <m:t>𝑁</m:t>
+                          </m:r>
+                          <m:r>
+                            <a:rPr lang="en-US" sz="3400" b="0" i="1" u="none" strike="noStrike" smtClean="0">
+                              <a:solidFill>
+                                <a:srgbClr val="000000"/>
+                              </a:solidFill>
+                              <a:effectLst/>
+                              <a:latin typeface="Cambria Math" panose="02040503050406030204" pitchFamily="18" charset="0"/>
+                              <a:ea typeface="Lato" panose="020F0502020204030203" pitchFamily="34" charset="0"/>
+                              <a:cs typeface="Arial" panose="020B0604020202020204" pitchFamily="34" charset="0"/>
+                            </a:rPr>
+                            <m:t>(</m:t>
+                          </m:r>
+                          <m:r>
+                            <a:rPr lang="en-US" sz="3400" b="0" i="1" u="none" strike="noStrike" smtClean="0">
+                              <a:solidFill>
+                                <a:srgbClr val="000000"/>
+                              </a:solidFill>
+                              <a:effectLst/>
+                              <a:latin typeface="Cambria Math" panose="02040503050406030204" pitchFamily="18" charset="0"/>
+                              <a:ea typeface="Lato" panose="020F0502020204030203" pitchFamily="34" charset="0"/>
+                              <a:cs typeface="Arial" panose="020B0604020202020204" pitchFamily="34" charset="0"/>
+                            </a:rPr>
+                            <m:t>𝑁</m:t>
+                          </m:r>
+                          <m:r>
+                            <a:rPr lang="en-US" sz="3400" b="0" i="1" u="none" strike="noStrike" smtClean="0">
+                              <a:solidFill>
+                                <a:srgbClr val="000000"/>
+                              </a:solidFill>
+                              <a:effectLst/>
+                              <a:latin typeface="Cambria Math" panose="02040503050406030204" pitchFamily="18" charset="0"/>
+                              <a:ea typeface="Lato" panose="020F0502020204030203" pitchFamily="34" charset="0"/>
+                              <a:cs typeface="Arial" panose="020B0604020202020204" pitchFamily="34" charset="0"/>
+                            </a:rPr>
+                            <m:t>+1)</m:t>
+                          </m:r>
+                        </m:den>
+                      </m:f>
+                      <m:r>
+                        <a:rPr lang="en-US" sz="3400" b="0" i="1" u="none" strike="noStrike" smtClean="0">
+                          <a:solidFill>
+                            <a:srgbClr val="000000"/>
+                          </a:solidFill>
+                          <a:effectLst/>
+                          <a:latin typeface="Cambria Math" panose="02040503050406030204" pitchFamily="18" charset="0"/>
+                          <a:ea typeface="Lato" panose="020F0502020204030203" pitchFamily="34" charset="0"/>
+                          <a:cs typeface="Arial" panose="020B0604020202020204" pitchFamily="34" charset="0"/>
+                        </a:rPr>
+                        <m:t> </m:t>
+                      </m:r>
+                      <m:nary>
+                        <m:naryPr>
+                          <m:chr m:val="∑"/>
+                          <m:ctrlPr>
+                            <a:rPr lang="en-US" sz="3400" b="0" i="1" u="none" strike="noStrike" smtClean="0">
+                              <a:solidFill>
+                                <a:srgbClr val="000000"/>
+                              </a:solidFill>
+                              <a:effectLst/>
+                              <a:latin typeface="Cambria Math" panose="02040503050406030204" pitchFamily="18" charset="0"/>
+                              <a:ea typeface="Lato" panose="020F0502020204030203" pitchFamily="34" charset="0"/>
+                              <a:cs typeface="Arial" panose="020B0604020202020204" pitchFamily="34" charset="0"/>
+                            </a:rPr>
+                          </m:ctrlPr>
+                        </m:naryPr>
+                        <m:sub>
+                          <m:r>
+                            <m:rPr>
+                              <m:brk m:alnAt="23"/>
+                            </m:rPr>
+                            <a:rPr lang="en-US" sz="3400" b="0" i="1" u="none" strike="noStrike" smtClean="0">
+                              <a:solidFill>
+                                <a:srgbClr val="000000"/>
+                              </a:solidFill>
+                              <a:effectLst/>
+                              <a:latin typeface="Cambria Math" panose="02040503050406030204" pitchFamily="18" charset="0"/>
+                              <a:ea typeface="Lato" panose="020F0502020204030203" pitchFamily="34" charset="0"/>
+                              <a:cs typeface="Arial" panose="020B0604020202020204" pitchFamily="34" charset="0"/>
+                            </a:rPr>
+                            <m:t>𝑖</m:t>
+                          </m:r>
+                          <m:r>
+                            <a:rPr lang="en-US" sz="3400" b="0" i="1" u="none" strike="noStrike" smtClean="0">
+                              <a:solidFill>
+                                <a:srgbClr val="000000"/>
+                              </a:solidFill>
+                              <a:effectLst/>
+                              <a:latin typeface="Cambria Math" panose="02040503050406030204" pitchFamily="18" charset="0"/>
+                              <a:ea typeface="Lato" panose="020F0502020204030203" pitchFamily="34" charset="0"/>
+                              <a:cs typeface="Arial" panose="020B0604020202020204" pitchFamily="34" charset="0"/>
+                            </a:rPr>
+                            <m:t>=1</m:t>
+                          </m:r>
+                        </m:sub>
+                        <m:sup>
+                          <m:r>
+                            <a:rPr lang="en-US" sz="3400" b="0" i="1" u="none" strike="noStrike" smtClean="0">
+                              <a:solidFill>
+                                <a:srgbClr val="000000"/>
+                              </a:solidFill>
+                              <a:effectLst/>
+                              <a:latin typeface="Cambria Math" panose="02040503050406030204" pitchFamily="18" charset="0"/>
+                              <a:ea typeface="Lato" panose="020F0502020204030203" pitchFamily="34" charset="0"/>
+                              <a:cs typeface="Arial" panose="020B0604020202020204" pitchFamily="34" charset="0"/>
+                            </a:rPr>
+                            <m:t>𝑘</m:t>
+                          </m:r>
+                        </m:sup>
+                        <m:e>
+                          <m:f>
+                            <m:fPr>
+                              <m:ctrlPr>
+                                <a:rPr lang="en-US" sz="3400" b="0" i="1" u="none" strike="noStrike" smtClean="0">
+                                  <a:solidFill>
+                                    <a:srgbClr val="000000"/>
+                                  </a:solidFill>
+                                  <a:effectLst/>
+                                  <a:latin typeface="Cambria Math" panose="02040503050406030204" pitchFamily="18" charset="0"/>
+                                  <a:ea typeface="Lato" panose="020F0502020204030203" pitchFamily="34" charset="0"/>
+                                  <a:cs typeface="Arial" panose="020B0604020202020204" pitchFamily="34" charset="0"/>
+                                </a:rPr>
+                              </m:ctrlPr>
+                            </m:fPr>
+                            <m:num>
+                              <m:sSubSup>
+                                <m:sSubSupPr>
+                                  <m:ctrlPr>
+                                    <a:rPr lang="en-US" sz="3400" b="0" i="1" u="none" strike="noStrike" smtClean="0">
+                                      <a:solidFill>
+                                        <a:srgbClr val="000000"/>
+                                      </a:solidFill>
+                                      <a:effectLst/>
+                                      <a:latin typeface="Cambria Math" panose="02040503050406030204" pitchFamily="18" charset="0"/>
+                                      <a:ea typeface="Lato" panose="020F0502020204030203" pitchFamily="34" charset="0"/>
+                                      <a:cs typeface="Arial" panose="020B0604020202020204" pitchFamily="34" charset="0"/>
+                                    </a:rPr>
+                                  </m:ctrlPr>
+                                </m:sSubSupPr>
+                                <m:e>
+                                  <m:r>
+                                    <a:rPr lang="en-US" sz="3400" b="0" i="1" u="none" strike="noStrike" smtClean="0">
+                                      <a:solidFill>
+                                        <a:srgbClr val="000000"/>
+                                      </a:solidFill>
+                                      <a:effectLst/>
+                                      <a:latin typeface="Cambria Math" panose="02040503050406030204" pitchFamily="18" charset="0"/>
+                                      <a:ea typeface="Lato" panose="020F0502020204030203" pitchFamily="34" charset="0"/>
+                                      <a:cs typeface="Arial" panose="020B0604020202020204" pitchFamily="34" charset="0"/>
+                                    </a:rPr>
+                                    <m:t>𝑅</m:t>
+                                  </m:r>
+                                </m:e>
+                                <m:sub>
+                                  <m:r>
+                                    <a:rPr lang="en-US" sz="3400" b="0" i="1" u="none" strike="noStrike" smtClean="0">
+                                      <a:solidFill>
+                                        <a:srgbClr val="000000"/>
+                                      </a:solidFill>
+                                      <a:effectLst/>
+                                      <a:latin typeface="Cambria Math" panose="02040503050406030204" pitchFamily="18" charset="0"/>
+                                      <a:ea typeface="Lato" panose="020F0502020204030203" pitchFamily="34" charset="0"/>
+                                      <a:cs typeface="Arial" panose="020B0604020202020204" pitchFamily="34" charset="0"/>
+                                    </a:rPr>
+                                    <m:t>𝑖</m:t>
+                                  </m:r>
+                                </m:sub>
+                                <m:sup>
+                                  <m:r>
+                                    <a:rPr lang="en-US" sz="3400" b="0" i="1" u="none" strike="noStrike" smtClean="0">
+                                      <a:solidFill>
+                                        <a:srgbClr val="000000"/>
+                                      </a:solidFill>
+                                      <a:effectLst/>
+                                      <a:latin typeface="Cambria Math" panose="02040503050406030204" pitchFamily="18" charset="0"/>
+                                      <a:ea typeface="Lato" panose="020F0502020204030203" pitchFamily="34" charset="0"/>
+                                      <a:cs typeface="Arial" panose="020B0604020202020204" pitchFamily="34" charset="0"/>
+                                    </a:rPr>
+                                    <m:t>2</m:t>
+                                  </m:r>
+                                </m:sup>
+                              </m:sSubSup>
+                            </m:num>
+                            <m:den>
+                              <m:sSub>
+                                <m:sSubPr>
+                                  <m:ctrlPr>
+                                    <a:rPr lang="en-US" sz="3400" b="0" i="1" u="none" strike="noStrike" smtClean="0">
+                                      <a:solidFill>
+                                        <a:srgbClr val="000000"/>
+                                      </a:solidFill>
+                                      <a:effectLst/>
+                                      <a:latin typeface="Cambria Math" panose="02040503050406030204" pitchFamily="18" charset="0"/>
+                                      <a:ea typeface="Lato" panose="020F0502020204030203" pitchFamily="34" charset="0"/>
+                                      <a:cs typeface="Arial" panose="020B0604020202020204" pitchFamily="34" charset="0"/>
+                                    </a:rPr>
+                                  </m:ctrlPr>
+                                </m:sSubPr>
+                                <m:e>
+                                  <m:r>
+                                    <a:rPr lang="en-US" sz="3400" b="0" i="1" u="none" strike="noStrike" smtClean="0">
+                                      <a:solidFill>
+                                        <a:srgbClr val="000000"/>
+                                      </a:solidFill>
+                                      <a:effectLst/>
+                                      <a:latin typeface="Cambria Math" panose="02040503050406030204" pitchFamily="18" charset="0"/>
+                                      <a:ea typeface="Lato" panose="020F0502020204030203" pitchFamily="34" charset="0"/>
+                                      <a:cs typeface="Arial" panose="020B0604020202020204" pitchFamily="34" charset="0"/>
+                                    </a:rPr>
+                                    <m:t>𝑛</m:t>
+                                  </m:r>
+                                </m:e>
+                                <m:sub>
+                                  <m:r>
+                                    <a:rPr lang="en-US" sz="3400" b="0" i="1" u="none" strike="noStrike" smtClean="0">
+                                      <a:solidFill>
+                                        <a:srgbClr val="000000"/>
+                                      </a:solidFill>
+                                      <a:effectLst/>
+                                      <a:latin typeface="Cambria Math" panose="02040503050406030204" pitchFamily="18" charset="0"/>
+                                      <a:ea typeface="Lato" panose="020F0502020204030203" pitchFamily="34" charset="0"/>
+                                      <a:cs typeface="Arial" panose="020B0604020202020204" pitchFamily="34" charset="0"/>
+                                    </a:rPr>
+                                    <m:t>𝑖</m:t>
+                                  </m:r>
+                                </m:sub>
+                              </m:sSub>
+                            </m:den>
+                          </m:f>
+                          <m:r>
+                            <a:rPr lang="en-US" sz="3400" b="0" i="1" u="none" strike="noStrike" smtClean="0">
+                              <a:solidFill>
+                                <a:srgbClr val="000000"/>
+                              </a:solidFill>
+                              <a:effectLst/>
+                              <a:latin typeface="Cambria Math" panose="02040503050406030204" pitchFamily="18" charset="0"/>
+                              <a:ea typeface="Lato" panose="020F0502020204030203" pitchFamily="34" charset="0"/>
+                              <a:cs typeface="Arial" panose="020B0604020202020204" pitchFamily="34" charset="0"/>
+                            </a:rPr>
+                            <m:t>−3(</m:t>
+                          </m:r>
+                          <m:r>
+                            <a:rPr lang="en-US" sz="3400" b="0" i="1" u="none" strike="noStrike" smtClean="0">
+                              <a:solidFill>
+                                <a:srgbClr val="000000"/>
+                              </a:solidFill>
+                              <a:effectLst/>
+                              <a:latin typeface="Cambria Math" panose="02040503050406030204" pitchFamily="18" charset="0"/>
+                              <a:ea typeface="Lato" panose="020F0502020204030203" pitchFamily="34" charset="0"/>
+                              <a:cs typeface="Arial" panose="020B0604020202020204" pitchFamily="34" charset="0"/>
+                            </a:rPr>
+                            <m:t>𝑁</m:t>
+                          </m:r>
+                          <m:r>
+                            <a:rPr lang="en-US" sz="3400" b="0" i="1" u="none" strike="noStrike" smtClean="0">
+                              <a:solidFill>
+                                <a:srgbClr val="000000"/>
+                              </a:solidFill>
+                              <a:effectLst/>
+                              <a:latin typeface="Cambria Math" panose="02040503050406030204" pitchFamily="18" charset="0"/>
+                              <a:ea typeface="Lato" panose="020F0502020204030203" pitchFamily="34" charset="0"/>
+                              <a:cs typeface="Arial" panose="020B0604020202020204" pitchFamily="34" charset="0"/>
+                            </a:rPr>
+                            <m:t>+1)</m:t>
+                          </m:r>
+                        </m:e>
+                      </m:nary>
+                    </m:oMath>
+                  </m:oMathPara>
+                </a14:m>
+                <a:endParaRPr lang="en-US" sz="3400" dirty="0">
+                  <a:latin typeface="Arial" panose="020B0604020202020204" pitchFamily="34" charset="0"/>
+                  <a:cs typeface="Arial" panose="020B0604020202020204" pitchFamily="34" charset="0"/>
+                </a:endParaRPr>
+              </a:p>
+            </p:txBody>
+          </p:sp>
+        </mc:Choice>
+        <mc:Fallback>
+          <p:sp>
+            <p:nvSpPr>
+              <p:cNvPr id="1047" name="TextBox 1046">
+                <a:extLst>
+                  <a:ext uri="{FF2B5EF4-FFF2-40B4-BE49-F238E27FC236}">
+                    <a16:creationId xmlns:a16="http://schemas.microsoft.com/office/drawing/2014/main" id="{916C0D3D-F044-D54B-CD11-61C3CD3FD552}"/>
+                  </a:ext>
+                </a:extLst>
+              </p:cNvPr>
+              <p:cNvSpPr txBox="1">
+                <a:spLocks noRot="1" noChangeAspect="1" noMove="1" noResize="1" noEditPoints="1" noAdjustHandles="1" noChangeArrowheads="1" noChangeShapeType="1" noTextEdit="1"/>
+              </p:cNvSpPr>
+              <p:nvPr/>
+            </p:nvSpPr>
+            <p:spPr>
+              <a:xfrm>
+                <a:off x="4674181" y="13890310"/>
+                <a:ext cx="6929120" cy="1574085"/>
+              </a:xfrm>
+              <a:prstGeom prst="rect">
+                <a:avLst/>
+              </a:prstGeom>
+              <a:blipFill>
+                <a:blip r:embed="rId13"/>
+                <a:stretch>
+                  <a:fillRect t="-102400" b="-162400"/>
+                </a:stretch>
+              </a:blipFill>
+            </p:spPr>
+            <p:txBody>
+              <a:bodyPr/>
+              <a:lstStyle/>
+              <a:p>
+                <a:r>
+                  <a:rPr lang="en-US">
+                    <a:noFill/>
+                  </a:rPr>
+                  <a:t> </a:t>
+                </a:r>
+              </a:p>
+            </p:txBody>
+          </p:sp>
+        </mc:Fallback>
+      </mc:AlternateContent>
+      <p:sp>
+        <p:nvSpPr>
+          <p:cNvPr id="1048" name="TextBox 1047">
+            <a:extLst>
+              <a:ext uri="{FF2B5EF4-FFF2-40B4-BE49-F238E27FC236}">
+                <a16:creationId xmlns:a16="http://schemas.microsoft.com/office/drawing/2014/main" id="{66D4C57C-3F3F-4D4F-2B21-718482350D53}"/>
+              </a:ext>
+            </a:extLst>
+          </p:cNvPr>
+          <p:cNvSpPr txBox="1"/>
+          <p:nvPr/>
+        </p:nvSpPr>
+        <p:spPr>
+          <a:xfrm>
+            <a:off x="2866390" y="28594705"/>
+            <a:ext cx="10520186" cy="1015663"/>
+          </a:xfrm>
+          <a:prstGeom prst="rect">
+            <a:avLst/>
+          </a:prstGeom>
+          <a:noFill/>
+        </p:spPr>
+        <p:txBody>
+          <a:bodyPr wrap="square" rtlCol="0">
+            <a:spAutoFit/>
+          </a:bodyPr>
+          <a:lstStyle/>
+          <a:p>
+            <a:r>
+              <a:rPr lang="en-US" sz="3000" dirty="0">
+                <a:latin typeface="Arial" panose="020B0604020202020204" pitchFamily="34" charset="0"/>
+                <a:cs typeface="Arial" panose="020B0604020202020204" pitchFamily="34" charset="0"/>
+              </a:rPr>
+              <a:t>The full module and analysis can be found at the SCORE Network’s preprint module repository</a:t>
+            </a:r>
+          </a:p>
+        </p:txBody>
+      </p:sp>
     </p:spTree>
     <p:extLst>
       <p:ext uri="{BB962C8B-B14F-4D97-AF65-F5344CB8AC3E}">
@@ -6755,6 +7612,11 @@
   <p:clrMapOvr>
     <a:masterClrMapping/>
   </p:clrMapOvr>
+  <p:extLst>
+    <p:ext uri="{6950BFC3-D8DA-4A85-94F7-54DA5524770B}">
+      <p188:commentRel xmlns:p188="http://schemas.microsoft.com/office/powerpoint/2018/8/main" r:id="rId2"/>
+    </p:ext>
+  </p:extLst>
 </p:sld>
 </file>
 

</xml_diff>